<commit_message>
fix(slides): title contrast on light bgs, table cell width, bottom margins (QA fixes)
</commit_message>
<xml_diff>
--- a/slides/KernelOlympics_Deck.pptx
+++ b/slides/KernelOlympics_Deck.pptx
@@ -1615,7 +1615,7 @@
         </p:nvSpPr>
         <p:spPr>
           <a:xfrm>
-            <a:off x="640080" y="914400"/>
+            <a:off x="640080" y="822960"/>
             <a:ext cx="7772400" cy="1097280"/>
           </a:xfrm>
           <a:prstGeom prst="rect">
@@ -1654,7 +1654,7 @@
         </p:nvSpPr>
         <p:spPr>
           <a:xfrm>
-            <a:off x="640080" y="2011680"/>
+            <a:off x="640080" y="1920240"/>
             <a:ext cx="7772400" cy="640080"/>
           </a:xfrm>
           <a:prstGeom prst="rect">
@@ -1693,7 +1693,7 @@
         </p:nvSpPr>
         <p:spPr>
           <a:xfrm>
-            <a:off x="640080" y="2651760"/>
+            <a:off x="640080" y="2560320"/>
             <a:ext cx="7772400" cy="457200"/>
           </a:xfrm>
           <a:prstGeom prst="rect">
@@ -1732,7 +1732,7 @@
         </p:nvSpPr>
         <p:spPr>
           <a:xfrm>
-            <a:off x="640080" y="3200400"/>
+            <a:off x="640080" y="3154680"/>
             <a:ext cx="2743200" cy="0"/>
           </a:xfrm>
           <a:prstGeom prst="line">
@@ -1755,8 +1755,8 @@
         </p:nvSpPr>
         <p:spPr>
           <a:xfrm>
-            <a:off x="640080" y="3474720"/>
-            <a:ext cx="7772400" cy="640080"/>
+            <a:off x="640080" y="3383280"/>
+            <a:ext cx="7772400" cy="548640"/>
           </a:xfrm>
           <a:prstGeom prst="rect">
             <a:avLst/>
@@ -1811,8 +1811,8 @@
         </p:nvSpPr>
         <p:spPr>
           <a:xfrm>
-            <a:off x="0" y="4846320"/>
-            <a:ext cx="9144000" cy="297180"/>
+            <a:off x="0" y="4754880"/>
+            <a:ext cx="9144000" cy="388620"/>
           </a:xfrm>
           <a:prstGeom prst="rect">
             <a:avLst/>
@@ -1831,8 +1831,8 @@
         </p:nvSpPr>
         <p:spPr>
           <a:xfrm>
-            <a:off x="457200" y="4846320"/>
-            <a:ext cx="8229600" cy="297180"/>
+            <a:off x="274320" y="4773168"/>
+            <a:ext cx="8595360" cy="365760"/>
           </a:xfrm>
           <a:prstGeom prst="rect">
             <a:avLst/>
@@ -1941,7 +1941,7 @@
             <a:r>
               <a:rPr lang="en-US" sz="2200" b="1" dirty="0">
                 <a:solidFill>
-                  <a:srgbClr val="FFFFFF"/>
+                  <a:srgbClr val="222222"/>
                 </a:solidFill>
                 <a:latin typeface="Calibri" pitchFamily="34" charset="0"/>
                 <a:ea typeface="Calibri" pitchFamily="34" charset="-122"/>
@@ -1962,7 +1962,7 @@
         <p:spPr>
           <a:xfrm>
             <a:off x="457200" y="1005840"/>
-            <a:ext cx="3840480" cy="3474720"/>
+            <a:ext cx="3840480" cy="3291840"/>
           </a:xfrm>
           <a:prstGeom prst="rect">
             <a:avLst/>
@@ -1974,7 +1974,7 @@
           <a:effectLst>
             <a:outerShdw sx="100000" sy="100000" kx="0" ky="0" algn="bl" rotWithShape="0" blurRad="101600" dist="38100" dir="8100000">
               <a:srgbClr val="000000">
-                <a:alpha val="30000"/>
+                <a:alpha val="25000"/>
               </a:srgbClr>
             </a:outerShdw>
           </a:effectLst>
@@ -1989,7 +1989,7 @@
         <p:spPr>
           <a:xfrm>
             <a:off x="640080" y="1097280"/>
-            <a:ext cx="3474720" cy="822960"/>
+            <a:ext cx="3474720" cy="731520"/>
           </a:xfrm>
           <a:prstGeom prst="rect">
             <a:avLst/>
@@ -2027,7 +2027,7 @@
         </p:nvSpPr>
         <p:spPr>
           <a:xfrm>
-            <a:off x="640080" y="1828800"/>
+            <a:off x="640080" y="1783080"/>
             <a:ext cx="3474720" cy="365760"/>
           </a:xfrm>
           <a:prstGeom prst="rect">
@@ -2066,8 +2066,8 @@
         </p:nvSpPr>
         <p:spPr>
           <a:xfrm>
-            <a:off x="640080" y="2560320"/>
-            <a:ext cx="3474720" cy="822960"/>
+            <a:off x="640080" y="2286000"/>
+            <a:ext cx="3474720" cy="731520"/>
           </a:xfrm>
           <a:prstGeom prst="rect">
             <a:avLst/>
@@ -2105,7 +2105,7 @@
         </p:nvSpPr>
         <p:spPr>
           <a:xfrm>
-            <a:off x="640080" y="3291840"/>
+            <a:off x="640080" y="3017520"/>
             <a:ext cx="3474720" cy="548640"/>
           </a:xfrm>
           <a:prstGeom prst="rect">
@@ -2145,7 +2145,7 @@
         <p:spPr>
           <a:xfrm>
             <a:off x="4754880" y="1005840"/>
-            <a:ext cx="3931920" cy="3474720"/>
+            <a:ext cx="3931920" cy="3291840"/>
           </a:xfrm>
           <a:prstGeom prst="rect">
             <a:avLst/>
@@ -2157,7 +2157,7 @@
           <a:effectLst>
             <a:outerShdw sx="100000" sy="100000" kx="0" ky="0" algn="bl" rotWithShape="0" blurRad="101600" dist="38100" dir="8100000">
               <a:srgbClr val="000000">
-                <a:alpha val="30000"/>
+                <a:alpha val="25000"/>
               </a:srgbClr>
             </a:outerShdw>
           </a:effectLst>
@@ -2211,7 +2211,7 @@
         <p:spPr>
           <a:xfrm>
             <a:off x="4937760" y="1691640"/>
-            <a:ext cx="3566160" cy="365760"/>
+            <a:ext cx="3566160" cy="320040"/>
           </a:xfrm>
           <a:prstGeom prst="rect">
             <a:avLst/>
@@ -2249,7 +2249,7 @@
         </p:nvSpPr>
         <p:spPr>
           <a:xfrm>
-            <a:off x="4937760" y="2377440"/>
+            <a:off x="4937760" y="2286000"/>
             <a:ext cx="3566160" cy="640080"/>
           </a:xfrm>
           <a:prstGeom prst="rect">
@@ -2288,8 +2288,8 @@
         </p:nvSpPr>
         <p:spPr>
           <a:xfrm>
-            <a:off x="4937760" y="2971800"/>
-            <a:ext cx="3566160" cy="365760"/>
+            <a:off x="4937760" y="2880360"/>
+            <a:ext cx="3566160" cy="320040"/>
           </a:xfrm>
           <a:prstGeom prst="rect">
             <a:avLst/>
@@ -2313,7 +2313,7 @@
                 <a:ea typeface="Calibri" pitchFamily="34" charset="-122"/>
                 <a:cs typeface="Calibri" pitchFamily="34" charset="-120"/>
               </a:rPr>
-              <a:t>CUDA kernels per average large codebase</a:t>
+              <a:t>CUDA kernels per large codebase</a:t>
             </a:r>
             <a:endParaRPr lang="en-US" sz="1300" dirty="0"/>
           </a:p>
@@ -2327,7 +2327,7 @@
         </p:nvSpPr>
         <p:spPr>
           <a:xfrm>
-            <a:off x="4937760" y="3657600"/>
+            <a:off x="4937760" y="3474720"/>
             <a:ext cx="3566160" cy="457200"/>
           </a:xfrm>
           <a:prstGeom prst="rect">
@@ -2366,8 +2366,8 @@
         </p:nvSpPr>
         <p:spPr>
           <a:xfrm>
-            <a:off x="0" y="4663440"/>
-            <a:ext cx="9144000" cy="480060"/>
+            <a:off x="0" y="4572000"/>
+            <a:ext cx="9144000" cy="571500"/>
           </a:xfrm>
           <a:prstGeom prst="rect">
             <a:avLst/>
@@ -2386,7 +2386,7 @@
         </p:nvSpPr>
         <p:spPr>
           <a:xfrm>
-            <a:off x="457200" y="4709160"/>
+            <a:off x="457200" y="4663440"/>
             <a:ext cx="8229600" cy="411480"/>
           </a:xfrm>
           <a:prstGeom prst="rect">
@@ -2425,7 +2425,7 @@
         </p:nvSpPr>
         <p:spPr>
           <a:xfrm>
-            <a:off x="7772400" y="4572000"/>
+            <a:off x="7772400" y="4754880"/>
             <a:ext cx="1097280" cy="320040"/>
           </a:xfrm>
           <a:prstGeom prst="rect">
@@ -2621,7 +2621,7 @@
         </p:nvSpPr>
         <p:spPr>
           <a:xfrm>
-            <a:off x="457200" y="1417320"/>
+            <a:off x="457200" y="1371600"/>
             <a:ext cx="1234440" cy="457200"/>
           </a:xfrm>
           <a:prstGeom prst="rect">
@@ -2638,7 +2638,7 @@
               <a:buNone/>
             </a:pPr>
             <a:r>
-              <a:rPr lang="en-US" sz="1100" b="1" dirty="0">
+              <a:rPr lang="en-US" sz="1200" b="1" dirty="0">
                 <a:solidFill>
                   <a:srgbClr val="FFFFFF"/>
                 </a:solidFill>
@@ -2646,9 +2646,9 @@
                 <a:ea typeface="Calibri" pitchFamily="34" charset="-122"/>
                 <a:cs typeface="Calibri" pitchFamily="34" charset="-120"/>
               </a:rPr>
-              <a:t>📡  SCAN</a:t>
-            </a:r>
-            <a:endParaRPr lang="en-US" sz="1100" dirty="0"/>
+              <a:t>🛡  SCAN</a:t>
+            </a:r>
+            <a:endParaRPr lang="en-US" sz="1200" dirty="0"/>
           </a:p>
         </p:txBody>
       </p:sp>
@@ -2660,8 +2660,8 @@
         </p:nvSpPr>
         <p:spPr>
           <a:xfrm>
-            <a:off x="457200" y="1920240"/>
-            <a:ext cx="1234440" cy="1005840"/>
+            <a:off x="457200" y="1874520"/>
+            <a:ext cx="1234440" cy="914400"/>
           </a:xfrm>
           <a:prstGeom prst="rect">
             <a:avLst/>
@@ -2782,7 +2782,7 @@
         </p:nvSpPr>
         <p:spPr>
           <a:xfrm>
-            <a:off x="1856232" y="1417320"/>
+            <a:off x="1856232" y="1371600"/>
             <a:ext cx="1234440" cy="457200"/>
           </a:xfrm>
           <a:prstGeom prst="rect">
@@ -2799,7 +2799,7 @@
               <a:buNone/>
             </a:pPr>
             <a:r>
-              <a:rPr lang="en-US" sz="1100" b="1" dirty="0">
+              <a:rPr lang="en-US" sz="1200" b="1" dirty="0">
                 <a:solidFill>
                   <a:srgbClr val="FFFFFF"/>
                 </a:solidFill>
@@ -2809,7 +2809,7 @@
               </a:rPr>
               <a:t>🧠  PLAN</a:t>
             </a:r>
-            <a:endParaRPr lang="en-US" sz="1100" dirty="0"/>
+            <a:endParaRPr lang="en-US" sz="1200" dirty="0"/>
           </a:p>
         </p:txBody>
       </p:sp>
@@ -2821,8 +2821,8 @@
         </p:nvSpPr>
         <p:spPr>
           <a:xfrm>
-            <a:off x="1856232" y="1920240"/>
-            <a:ext cx="1234440" cy="1005840"/>
+            <a:off x="1856232" y="1874520"/>
+            <a:ext cx="1234440" cy="914400"/>
           </a:xfrm>
           <a:prstGeom prst="rect">
             <a:avLst/>
@@ -2943,7 +2943,7 @@
         </p:nvSpPr>
         <p:spPr>
           <a:xfrm>
-            <a:off x="3255264" y="1417320"/>
+            <a:off x="3255264" y="1371600"/>
             <a:ext cx="1234440" cy="457200"/>
           </a:xfrm>
           <a:prstGeom prst="rect">
@@ -2960,7 +2960,7 @@
               <a:buNone/>
             </a:pPr>
             <a:r>
-              <a:rPr lang="en-US" sz="1100" b="1" dirty="0">
+              <a:rPr lang="en-US" sz="1200" b="1" dirty="0">
                 <a:solidFill>
                   <a:srgbClr val="FFFFFF"/>
                 </a:solidFill>
@@ -2970,7 +2970,7 @@
               </a:rPr>
               <a:t>⚡  PORT</a:t>
             </a:r>
-            <a:endParaRPr lang="en-US" sz="1100" dirty="0"/>
+            <a:endParaRPr lang="en-US" sz="1200" dirty="0"/>
           </a:p>
         </p:txBody>
       </p:sp>
@@ -2982,8 +2982,8 @@
         </p:nvSpPr>
         <p:spPr>
           <a:xfrm>
-            <a:off x="3255264" y="1920240"/>
-            <a:ext cx="1234440" cy="1005840"/>
+            <a:off x="3255264" y="1874520"/>
+            <a:ext cx="1234440" cy="914400"/>
           </a:xfrm>
           <a:prstGeom prst="rect">
             <a:avLst/>
@@ -3104,7 +3104,7 @@
         </p:nvSpPr>
         <p:spPr>
           <a:xfrm>
-            <a:off x="4654296" y="1417320"/>
+            <a:off x="4654296" y="1371600"/>
             <a:ext cx="1234440" cy="457200"/>
           </a:xfrm>
           <a:prstGeom prst="rect">
@@ -3121,7 +3121,7 @@
               <a:buNone/>
             </a:pPr>
             <a:r>
-              <a:rPr lang="en-US" sz="1100" b="1" dirty="0">
+              <a:rPr lang="en-US" sz="1200" b="1" dirty="0">
                 <a:solidFill>
                   <a:srgbClr val="FFFFFF"/>
                 </a:solidFill>
@@ -3131,7 +3131,7 @@
               </a:rPr>
               <a:t>🔍  EVAL</a:t>
             </a:r>
-            <a:endParaRPr lang="en-US" sz="1100" dirty="0"/>
+            <a:endParaRPr lang="en-US" sz="1200" dirty="0"/>
           </a:p>
         </p:txBody>
       </p:sp>
@@ -3143,8 +3143,8 @@
         </p:nvSpPr>
         <p:spPr>
           <a:xfrm>
-            <a:off x="4654296" y="1920240"/>
-            <a:ext cx="1234440" cy="1005840"/>
+            <a:off x="4654296" y="1874520"/>
+            <a:ext cx="1234440" cy="914400"/>
           </a:xfrm>
           <a:prstGeom prst="rect">
             <a:avLst/>
@@ -3265,7 +3265,7 @@
         </p:nvSpPr>
         <p:spPr>
           <a:xfrm>
-            <a:off x="6053328" y="1417320"/>
+            <a:off x="6053328" y="1371600"/>
             <a:ext cx="1234440" cy="457200"/>
           </a:xfrm>
           <a:prstGeom prst="rect">
@@ -3282,7 +3282,7 @@
               <a:buNone/>
             </a:pPr>
             <a:r>
-              <a:rPr lang="en-US" sz="1100" b="1" dirty="0">
+              <a:rPr lang="en-US" sz="1200" b="1" dirty="0">
                 <a:solidFill>
                   <a:srgbClr val="FFFFFF"/>
                 </a:solidFill>
@@ -3292,7 +3292,7 @@
               </a:rPr>
               <a:t>✅  VERIFY</a:t>
             </a:r>
-            <a:endParaRPr lang="en-US" sz="1100" dirty="0"/>
+            <a:endParaRPr lang="en-US" sz="1200" dirty="0"/>
           </a:p>
         </p:txBody>
       </p:sp>
@@ -3304,8 +3304,8 @@
         </p:nvSpPr>
         <p:spPr>
           <a:xfrm>
-            <a:off x="6053328" y="1920240"/>
-            <a:ext cx="1234440" cy="1005840"/>
+            <a:off x="6053328" y="1874520"/>
+            <a:ext cx="1234440" cy="914400"/>
           </a:xfrm>
           <a:prstGeom prst="rect">
             <a:avLst/>
@@ -3426,7 +3426,7 @@
         </p:nvSpPr>
         <p:spPr>
           <a:xfrm>
-            <a:off x="7452360" y="1417320"/>
+            <a:off x="7452360" y="1371600"/>
             <a:ext cx="1234440" cy="457200"/>
           </a:xfrm>
           <a:prstGeom prst="rect">
@@ -3443,7 +3443,7 @@
               <a:buNone/>
             </a:pPr>
             <a:r>
-              <a:rPr lang="en-US" sz="1100" b="1" dirty="0">
+              <a:rPr lang="en-US" sz="1200" b="1" dirty="0">
                 <a:solidFill>
                   <a:srgbClr val="FFFFFF"/>
                 </a:solidFill>
@@ -3453,7 +3453,7 @@
               </a:rPr>
               <a:t>📋  REPORT</a:t>
             </a:r>
-            <a:endParaRPr lang="en-US" sz="1100" dirty="0"/>
+            <a:endParaRPr lang="en-US" sz="1200" dirty="0"/>
           </a:p>
         </p:txBody>
       </p:sp>
@@ -3465,8 +3465,8 @@
         </p:nvSpPr>
         <p:spPr>
           <a:xfrm>
-            <a:off x="7452360" y="1920240"/>
-            <a:ext cx="1234440" cy="1005840"/>
+            <a:off x="7452360" y="1874520"/>
+            <a:ext cx="1234440" cy="914400"/>
           </a:xfrm>
           <a:prstGeom prst="rect">
             <a:avLst/>
@@ -3521,14 +3521,14 @@
         </p:nvSpPr>
         <p:spPr>
           <a:xfrm>
-            <a:off x="0" y="4023360"/>
-            <a:ext cx="9144000" cy="1120140"/>
+            <a:off x="0" y="3931920"/>
+            <a:ext cx="9144000" cy="1211580"/>
           </a:xfrm>
           <a:prstGeom prst="rect">
             <a:avLst/>
           </a:prstGeom>
           <a:solidFill>
-            <a:srgbClr val="12121E"/>
+            <a:srgbClr val="0C0C18"/>
           </a:solidFill>
           <a:ln/>
         </p:spPr>
@@ -3541,7 +3541,7 @@
         </p:nvSpPr>
         <p:spPr>
           <a:xfrm>
-            <a:off x="731520" y="4160520"/>
+            <a:off x="731520" y="4069080"/>
             <a:ext cx="1828800" cy="457200"/>
           </a:xfrm>
           <a:prstGeom prst="rect">
@@ -3558,7 +3558,7 @@
               <a:buNone/>
             </a:pPr>
             <a:r>
-              <a:rPr lang="en-US" sz="2200" b="1" dirty="0">
+              <a:rPr lang="en-US" sz="2400" b="1" dirty="0">
                 <a:solidFill>
                   <a:srgbClr val="ED1C24"/>
                 </a:solidFill>
@@ -3568,7 +3568,7 @@
               </a:rPr>
               <a:t>~105s</a:t>
             </a:r>
-            <a:endParaRPr lang="en-US" sz="2200" dirty="0"/>
+            <a:endParaRPr lang="en-US" sz="2400" dirty="0"/>
           </a:p>
         </p:txBody>
       </p:sp>
@@ -3580,7 +3580,7 @@
         </p:nvSpPr>
         <p:spPr>
           <a:xfrm>
-            <a:off x="731520" y="4572000"/>
+            <a:off x="731520" y="4526280"/>
             <a:ext cx="1828800" cy="274320"/>
           </a:xfrm>
           <a:prstGeom prst="rect">
@@ -3619,7 +3619,7 @@
         </p:nvSpPr>
         <p:spPr>
           <a:xfrm>
-            <a:off x="2834640" y="4160520"/>
+            <a:off x="2834640" y="4069080"/>
             <a:ext cx="1828800" cy="457200"/>
           </a:xfrm>
           <a:prstGeom prst="rect">
@@ -3636,7 +3636,7 @@
               <a:buNone/>
             </a:pPr>
             <a:r>
-              <a:rPr lang="en-US" sz="2200" b="1" dirty="0">
+              <a:rPr lang="en-US" sz="2400" b="1" dirty="0">
                 <a:solidFill>
                   <a:srgbClr val="ED1C24"/>
                 </a:solidFill>
@@ -3646,7 +3646,7 @@
               </a:rPr>
               <a:t>~$0.03</a:t>
             </a:r>
-            <a:endParaRPr lang="en-US" sz="2200" dirty="0"/>
+            <a:endParaRPr lang="en-US" sz="2400" dirty="0"/>
           </a:p>
         </p:txBody>
       </p:sp>
@@ -3658,7 +3658,7 @@
         </p:nvSpPr>
         <p:spPr>
           <a:xfrm>
-            <a:off x="2834640" y="4572000"/>
+            <a:off x="2834640" y="4526280"/>
             <a:ext cx="1828800" cy="274320"/>
           </a:xfrm>
           <a:prstGeom prst="rect">
@@ -3697,7 +3697,7 @@
         </p:nvSpPr>
         <p:spPr>
           <a:xfrm>
-            <a:off x="4937760" y="4160520"/>
+            <a:off x="4937760" y="4069080"/>
             <a:ext cx="1828800" cy="457200"/>
           </a:xfrm>
           <a:prstGeom prst="rect">
@@ -3714,7 +3714,7 @@
               <a:buNone/>
             </a:pPr>
             <a:r>
-              <a:rPr lang="en-US" sz="2200" b="1" dirty="0">
+              <a:rPr lang="en-US" sz="2400" b="1" dirty="0">
                 <a:solidFill>
                   <a:srgbClr val="ED1C24"/>
                 </a:solidFill>
@@ -3724,7 +3724,7 @@
               </a:rPr>
               <a:t>30+/hr</a:t>
             </a:r>
-            <a:endParaRPr lang="en-US" sz="2200" dirty="0"/>
+            <a:endParaRPr lang="en-US" sz="2400" dirty="0"/>
           </a:p>
         </p:txBody>
       </p:sp>
@@ -3736,7 +3736,7 @@
         </p:nvSpPr>
         <p:spPr>
           <a:xfrm>
-            <a:off x="4937760" y="4572000"/>
+            <a:off x="4937760" y="4526280"/>
             <a:ext cx="1828800" cy="274320"/>
           </a:xfrm>
           <a:prstGeom prst="rect">
@@ -3775,7 +3775,7 @@
         </p:nvSpPr>
         <p:spPr>
           <a:xfrm>
-            <a:off x="7040880" y="4160520"/>
+            <a:off x="7040880" y="4069080"/>
             <a:ext cx="1828800" cy="457200"/>
           </a:xfrm>
           <a:prstGeom prst="rect">
@@ -3792,7 +3792,7 @@
               <a:buNone/>
             </a:pPr>
             <a:r>
-              <a:rPr lang="en-US" sz="2200" b="1" dirty="0">
+              <a:rPr lang="en-US" sz="2400" b="1" dirty="0">
                 <a:solidFill>
                   <a:srgbClr val="ED1C24"/>
                 </a:solidFill>
@@ -3802,7 +3802,7 @@
               </a:rPr>
               <a:t>&lt;1%</a:t>
             </a:r>
-            <a:endParaRPr lang="en-US" sz="2200" dirty="0"/>
+            <a:endParaRPr lang="en-US" sz="2400" dirty="0"/>
           </a:p>
         </p:txBody>
       </p:sp>
@@ -3814,7 +3814,7 @@
         </p:nvSpPr>
         <p:spPr>
           <a:xfrm>
-            <a:off x="7040880" y="4572000"/>
+            <a:off x="7040880" y="4526280"/>
             <a:ext cx="1828800" cy="274320"/>
           </a:xfrm>
           <a:prstGeom prst="rect">
@@ -3853,7 +3853,7 @@
         </p:nvSpPr>
         <p:spPr>
           <a:xfrm>
-            <a:off x="7772400" y="4572000"/>
+            <a:off x="7772400" y="4754880"/>
             <a:ext cx="1097280" cy="320040"/>
           </a:xfrm>
           <a:prstGeom prst="rect">
@@ -3963,7 +3963,7 @@
             <a:r>
               <a:rPr lang="en-US" sz="2200" b="1" dirty="0">
                 <a:solidFill>
-                  <a:srgbClr val="FFFFFF"/>
+                  <a:srgbClr val="222222"/>
                 </a:solidFill>
                 <a:latin typeface="Calibri" pitchFamily="34" charset="0"/>
                 <a:ea typeface="Calibri" pitchFamily="34" charset="-122"/>
@@ -3996,7 +3996,7 @@
           <a:effectLst>
             <a:outerShdw sx="100000" sy="100000" kx="0" ky="0" algn="bl" rotWithShape="0" blurRad="101600" dist="38100" dir="8100000">
               <a:srgbClr val="000000">
-                <a:alpha val="30000"/>
+                <a:alpha val="25000"/>
               </a:srgbClr>
             </a:outerShdw>
           </a:effectLst>
@@ -4027,7 +4027,7 @@
               <a:buNone/>
             </a:pPr>
             <a:r>
-              <a:rPr lang="en-US" sz="1300" b="1" dirty="0">
+              <a:rPr lang="en-US" sz="1400" b="1" dirty="0">
                 <a:solidFill>
                   <a:srgbClr val="FFFFFF"/>
                 </a:solidFill>
@@ -4037,7 +4037,7 @@
               </a:rPr>
               <a:t>DeepSeek v4</a:t>
             </a:r>
-            <a:endParaRPr lang="en-US" sz="1300" dirty="0"/>
+            <a:endParaRPr lang="en-US" sz="1400" dirty="0"/>
           </a:p>
         </p:txBody>
       </p:sp>
@@ -4082,7 +4082,46 @@
       </p:sp>
       <p:sp>
         <p:nvSpPr>
-          <p:cNvPr id="7" name="Shape 5"/>
+          <p:cNvPr id="7" name="Text 5"/>
+          <p:cNvSpPr/>
+          <p:nvPr/>
+        </p:nvSpPr>
+        <p:spPr>
+          <a:xfrm>
+            <a:off x="1394460" y="2286000"/>
+            <a:ext cx="1463040" cy="320040"/>
+          </a:xfrm>
+          <a:prstGeom prst="rect">
+            <a:avLst/>
+          </a:prstGeom>
+          <a:noFill/>
+          <a:ln/>
+        </p:spPr>
+        <p:txBody>
+          <a:bodyPr wrap="square" lIns="0" tIns="0" rIns="0" bIns="0" rtlCol="0" anchor="ctr"/>
+          <a:lstStyle/>
+          <a:p>
+            <a:pPr algn="ctr" indent="0" marL="0">
+              <a:buNone/>
+            </a:pPr>
+            <a:r>
+              <a:rPr lang="en-US" sz="1000" dirty="0">
+                <a:solidFill>
+                  <a:srgbClr val="777777"/>
+                </a:solidFill>
+                <a:latin typeface="Calibri Light" pitchFamily="34" charset="0"/>
+                <a:ea typeface="Calibri Light" pitchFamily="34" charset="-122"/>
+                <a:cs typeface="Calibri Light" pitchFamily="34" charset="-120"/>
+              </a:rPr>
+              <a:t>Plans structure</a:t>
+            </a:r>
+            <a:endParaRPr lang="en-US" sz="1000" dirty="0"/>
+          </a:p>
+        </p:txBody>
+      </p:sp>
+      <p:sp>
+        <p:nvSpPr>
+          <p:cNvPr id="8" name="Shape 6"/>
           <p:cNvSpPr/>
           <p:nvPr/>
         </p:nvSpPr>
@@ -4101,7 +4140,7 @@
           <a:effectLst>
             <a:outerShdw sx="100000" sy="100000" kx="0" ky="0" algn="bl" rotWithShape="0" blurRad="101600" dist="38100" dir="8100000">
               <a:srgbClr val="000000">
-                <a:alpha val="30000"/>
+                <a:alpha val="25000"/>
               </a:srgbClr>
             </a:outerShdw>
           </a:effectLst>
@@ -4109,7 +4148,7 @@
       </p:sp>
       <p:sp>
         <p:nvSpPr>
-          <p:cNvPr id="8" name="Text 6"/>
+          <p:cNvPr id="9" name="Text 7"/>
           <p:cNvSpPr/>
           <p:nvPr/>
         </p:nvSpPr>
@@ -4132,7 +4171,7 @@
               <a:buNone/>
             </a:pPr>
             <a:r>
-              <a:rPr lang="en-US" sz="1300" b="1" dirty="0">
+              <a:rPr lang="en-US" sz="1400" b="1" dirty="0">
                 <a:solidFill>
                   <a:srgbClr val="FFFFFF"/>
                 </a:solidFill>
@@ -4142,13 +4181,13 @@
               </a:rPr>
               <a:t>GLM-5.2</a:t>
             </a:r>
-            <a:endParaRPr lang="en-US" sz="1300" dirty="0"/>
-          </a:p>
-        </p:txBody>
-      </p:sp>
-      <p:sp>
-        <p:nvSpPr>
-          <p:cNvPr id="9" name="Text 7"/>
+            <a:endParaRPr lang="en-US" sz="1400" dirty="0"/>
+          </a:p>
+        </p:txBody>
+      </p:sp>
+      <p:sp>
+        <p:nvSpPr>
+          <p:cNvPr id="10" name="Text 8"/>
           <p:cNvSpPr/>
           <p:nvPr/>
         </p:nvSpPr>
@@ -4187,7 +4226,46 @@
       </p:sp>
       <p:sp>
         <p:nvSpPr>
-          <p:cNvPr id="10" name="Shape 8"/>
+          <p:cNvPr id="11" name="Text 9"/>
+          <p:cNvSpPr/>
+          <p:nvPr/>
+        </p:nvSpPr>
+        <p:spPr>
+          <a:xfrm>
+            <a:off x="3086100" y="2286000"/>
+            <a:ext cx="1280160" cy="320040"/>
+          </a:xfrm>
+          <a:prstGeom prst="rect">
+            <a:avLst/>
+          </a:prstGeom>
+          <a:noFill/>
+          <a:ln/>
+        </p:spPr>
+        <p:txBody>
+          <a:bodyPr wrap="square" lIns="0" tIns="0" rIns="0" bIns="0" rtlCol="0" anchor="ctr"/>
+          <a:lstStyle/>
+          <a:p>
+            <a:pPr algn="ctr" indent="0" marL="0">
+              <a:buNone/>
+            </a:pPr>
+            <a:r>
+              <a:rPr lang="en-US" sz="1000" dirty="0">
+                <a:solidFill>
+                  <a:srgbClr val="777777"/>
+                </a:solidFill>
+                <a:latin typeface="Calibri Light" pitchFamily="34" charset="0"/>
+                <a:ea typeface="Calibri Light" pitchFamily="34" charset="-122"/>
+                <a:cs typeface="Calibri Light" pitchFamily="34" charset="-120"/>
+              </a:rPr>
+              <a:t>Generates HIP</a:t>
+            </a:r>
+            <a:endParaRPr lang="en-US" sz="1000" dirty="0"/>
+          </a:p>
+        </p:txBody>
+      </p:sp>
+      <p:sp>
+        <p:nvSpPr>
+          <p:cNvPr id="12" name="Shape 10"/>
           <p:cNvSpPr/>
           <p:nvPr/>
         </p:nvSpPr>
@@ -4206,7 +4284,7 @@
           <a:effectLst>
             <a:outerShdw sx="100000" sy="100000" kx="0" ky="0" algn="bl" rotWithShape="0" blurRad="101600" dist="38100" dir="8100000">
               <a:srgbClr val="000000">
-                <a:alpha val="30000"/>
+                <a:alpha val="25000"/>
               </a:srgbClr>
             </a:outerShdw>
           </a:effectLst>
@@ -4214,7 +4292,7 @@
       </p:sp>
       <p:sp>
         <p:nvSpPr>
-          <p:cNvPr id="11" name="Text 9"/>
+          <p:cNvPr id="13" name="Text 11"/>
           <p:cNvSpPr/>
           <p:nvPr/>
         </p:nvSpPr>
@@ -4237,7 +4315,7 @@
               <a:buNone/>
             </a:pPr>
             <a:r>
-              <a:rPr lang="en-US" sz="1300" b="1" dirty="0">
+              <a:rPr lang="en-US" sz="1400" b="1" dirty="0">
                 <a:solidFill>
                   <a:srgbClr val="FFFFFF"/>
                 </a:solidFill>
@@ -4247,13 +4325,13 @@
               </a:rPr>
               <a:t>Kimi-K2.7</a:t>
             </a:r>
-            <a:endParaRPr lang="en-US" sz="1300" dirty="0"/>
-          </a:p>
-        </p:txBody>
-      </p:sp>
-      <p:sp>
-        <p:nvSpPr>
-          <p:cNvPr id="12" name="Text 10"/>
+            <a:endParaRPr lang="en-US" sz="1400" dirty="0"/>
+          </a:p>
+        </p:txBody>
+      </p:sp>
+      <p:sp>
+        <p:nvSpPr>
+          <p:cNvPr id="14" name="Text 12"/>
           <p:cNvSpPr/>
           <p:nvPr/>
         </p:nvSpPr>
@@ -4292,7 +4370,46 @@
       </p:sp>
       <p:sp>
         <p:nvSpPr>
-          <p:cNvPr id="13" name="Shape 11"/>
+          <p:cNvPr id="15" name="Text 13"/>
+          <p:cNvSpPr/>
+          <p:nvPr/>
+        </p:nvSpPr>
+        <p:spPr>
+          <a:xfrm>
+            <a:off x="4594860" y="2286000"/>
+            <a:ext cx="1463040" cy="320040"/>
+          </a:xfrm>
+          <a:prstGeom prst="rect">
+            <a:avLst/>
+          </a:prstGeom>
+          <a:noFill/>
+          <a:ln/>
+        </p:spPr>
+        <p:txBody>
+          <a:bodyPr wrap="square" lIns="0" tIns="0" rIns="0" bIns="0" rtlCol="0" anchor="ctr"/>
+          <a:lstStyle/>
+          <a:p>
+            <a:pPr algn="ctr" indent="0" marL="0">
+              <a:buNone/>
+            </a:pPr>
+            <a:r>
+              <a:rPr lang="en-US" sz="1000" dirty="0">
+                <a:solidFill>
+                  <a:srgbClr val="777777"/>
+                </a:solidFill>
+                <a:latin typeface="Calibri Light" pitchFamily="34" charset="0"/>
+                <a:ea typeface="Calibri Light" pitchFamily="34" charset="-122"/>
+                <a:cs typeface="Calibri Light" pitchFamily="34" charset="-120"/>
+              </a:rPr>
+              <a:t>Validates output</a:t>
+            </a:r>
+            <a:endParaRPr lang="en-US" sz="1000" dirty="0"/>
+          </a:p>
+        </p:txBody>
+      </p:sp>
+      <p:sp>
+        <p:nvSpPr>
+          <p:cNvPr id="16" name="Shape 14"/>
           <p:cNvSpPr/>
           <p:nvPr/>
         </p:nvSpPr>
@@ -4311,7 +4428,7 @@
           <a:effectLst>
             <a:outerShdw sx="100000" sy="100000" kx="0" ky="0" algn="bl" rotWithShape="0" blurRad="101600" dist="38100" dir="8100000">
               <a:srgbClr val="000000">
-                <a:alpha val="30000"/>
+                <a:alpha val="25000"/>
               </a:srgbClr>
             </a:outerShdw>
           </a:effectLst>
@@ -4319,7 +4436,7 @@
       </p:sp>
       <p:sp>
         <p:nvSpPr>
-          <p:cNvPr id="14" name="Text 12"/>
+          <p:cNvPr id="17" name="Text 15"/>
           <p:cNvSpPr/>
           <p:nvPr/>
         </p:nvSpPr>
@@ -4342,7 +4459,7 @@
               <a:buNone/>
             </a:pPr>
             <a:r>
-              <a:rPr lang="en-US" sz="1300" b="1" dirty="0">
+              <a:rPr lang="en-US" sz="1400" b="1" dirty="0">
                 <a:solidFill>
                   <a:srgbClr val="FFFFFF"/>
                 </a:solidFill>
@@ -4352,13 +4469,13 @@
               </a:rPr>
               <a:t>Gemma</a:t>
             </a:r>
-            <a:endParaRPr lang="en-US" sz="1300" dirty="0"/>
-          </a:p>
-        </p:txBody>
-      </p:sp>
-      <p:sp>
-        <p:nvSpPr>
-          <p:cNvPr id="15" name="Text 13"/>
+            <a:endParaRPr lang="en-US" sz="1400" dirty="0"/>
+          </a:p>
+        </p:txBody>
+      </p:sp>
+      <p:sp>
+        <p:nvSpPr>
+          <p:cNvPr id="18" name="Text 16"/>
           <p:cNvSpPr/>
           <p:nvPr/>
         </p:nvSpPr>
@@ -4397,13 +4514,13 @@
       </p:sp>
       <p:sp>
         <p:nvSpPr>
-          <p:cNvPr id="16" name="Text 14"/>
-          <p:cNvSpPr/>
-          <p:nvPr/>
-        </p:nvSpPr>
-        <p:spPr>
-          <a:xfrm>
-            <a:off x="1394460" y="2286000"/>
+          <p:cNvPr id="19" name="Text 17"/>
+          <p:cNvSpPr/>
+          <p:nvPr/>
+        </p:nvSpPr>
+        <p:spPr>
+          <a:xfrm>
+            <a:off x="6286500" y="2286000"/>
             <a:ext cx="1463040" cy="320040"/>
           </a:xfrm>
           <a:prstGeom prst="rect">
@@ -4420,30 +4537,30 @@
               <a:buNone/>
             </a:pPr>
             <a:r>
-              <a:rPr lang="en-US" sz="900" dirty="0">
-                <a:solidFill>
-                  <a:srgbClr val="888888"/>
+              <a:rPr lang="en-US" sz="1000" dirty="0">
+                <a:solidFill>
+                  <a:srgbClr val="777777"/>
                 </a:solidFill>
                 <a:latin typeface="Calibri Light" pitchFamily="34" charset="0"/>
                 <a:ea typeface="Calibri Light" pitchFamily="34" charset="-122"/>
                 <a:cs typeface="Calibri Light" pitchFamily="34" charset="-120"/>
               </a:rPr>
-              <a:t>Plans structure</a:t>
-            </a:r>
-            <a:endParaRPr lang="en-US" sz="900" dirty="0"/>
-          </a:p>
-        </p:txBody>
-      </p:sp>
-      <p:sp>
-        <p:nvSpPr>
-          <p:cNvPr id="17" name="Text 15"/>
-          <p:cNvSpPr/>
-          <p:nvPr/>
-        </p:nvSpPr>
-        <p:spPr>
-          <a:xfrm>
-            <a:off x="3086100" y="2286000"/>
-            <a:ext cx="1280160" cy="320040"/>
+              <a:t>Failsafe</a:t>
+            </a:r>
+            <a:endParaRPr lang="en-US" sz="1000" dirty="0"/>
+          </a:p>
+        </p:txBody>
+      </p:sp>
+      <p:sp>
+        <p:nvSpPr>
+          <p:cNvPr id="20" name="Text 18"/>
+          <p:cNvSpPr/>
+          <p:nvPr/>
+        </p:nvSpPr>
+        <p:spPr>
+          <a:xfrm>
+            <a:off x="2857500" y="1097280"/>
+            <a:ext cx="228600" cy="1097280"/>
           </a:xfrm>
           <a:prstGeom prst="rect">
             <a:avLst/>
@@ -4459,108 +4576,503 @@
               <a:buNone/>
             </a:pPr>
             <a:r>
-              <a:rPr lang="en-US" sz="900" dirty="0">
-                <a:solidFill>
-                  <a:srgbClr val="888888"/>
+              <a:rPr lang="en-US" sz="2000" dirty="0">
+                <a:solidFill>
+                  <a:srgbClr val="999999"/>
+                </a:solidFill>
+                <a:latin typeface="Calibri" pitchFamily="34" charset="0"/>
+                <a:ea typeface="Calibri" pitchFamily="34" charset="-122"/>
+                <a:cs typeface="Calibri" pitchFamily="34" charset="-120"/>
+              </a:rPr>
+              <a:t>→</a:t>
+            </a:r>
+            <a:endParaRPr lang="en-US" sz="2000" dirty="0"/>
+          </a:p>
+        </p:txBody>
+      </p:sp>
+      <p:sp>
+        <p:nvSpPr>
+          <p:cNvPr id="21" name="Text 19"/>
+          <p:cNvSpPr/>
+          <p:nvPr/>
+        </p:nvSpPr>
+        <p:spPr>
+          <a:xfrm>
+            <a:off x="4366260" y="1097280"/>
+            <a:ext cx="228600" cy="1097280"/>
+          </a:xfrm>
+          <a:prstGeom prst="rect">
+            <a:avLst/>
+          </a:prstGeom>
+          <a:noFill/>
+          <a:ln/>
+        </p:spPr>
+        <p:txBody>
+          <a:bodyPr wrap="square" lIns="0" tIns="0" rIns="0" bIns="0" rtlCol="0" anchor="ctr"/>
+          <a:lstStyle/>
+          <a:p>
+            <a:pPr algn="ctr" indent="0" marL="0">
+              <a:buNone/>
+            </a:pPr>
+            <a:r>
+              <a:rPr lang="en-US" sz="2000" dirty="0">
+                <a:solidFill>
+                  <a:srgbClr val="999999"/>
+                </a:solidFill>
+                <a:latin typeface="Calibri" pitchFamily="34" charset="0"/>
+                <a:ea typeface="Calibri" pitchFamily="34" charset="-122"/>
+                <a:cs typeface="Calibri" pitchFamily="34" charset="-120"/>
+              </a:rPr>
+              <a:t>→</a:t>
+            </a:r>
+            <a:endParaRPr lang="en-US" sz="2000" dirty="0"/>
+          </a:p>
+        </p:txBody>
+      </p:sp>
+      <p:sp>
+        <p:nvSpPr>
+          <p:cNvPr id="22" name="Text 20"/>
+          <p:cNvSpPr/>
+          <p:nvPr/>
+        </p:nvSpPr>
+        <p:spPr>
+          <a:xfrm>
+            <a:off x="6057900" y="1097280"/>
+            <a:ext cx="228600" cy="1097280"/>
+          </a:xfrm>
+          <a:prstGeom prst="rect">
+            <a:avLst/>
+          </a:prstGeom>
+          <a:noFill/>
+          <a:ln/>
+        </p:spPr>
+        <p:txBody>
+          <a:bodyPr wrap="square" lIns="0" tIns="0" rIns="0" bIns="0" rtlCol="0" anchor="ctr"/>
+          <a:lstStyle/>
+          <a:p>
+            <a:pPr algn="ctr" indent="0" marL="0">
+              <a:buNone/>
+            </a:pPr>
+            <a:r>
+              <a:rPr lang="en-US" sz="2000" dirty="0">
+                <a:solidFill>
+                  <a:srgbClr val="999999"/>
+                </a:solidFill>
+                <a:latin typeface="Calibri" pitchFamily="34" charset="0"/>
+                <a:ea typeface="Calibri" pitchFamily="34" charset="-122"/>
+                <a:cs typeface="Calibri" pitchFamily="34" charset="-120"/>
+              </a:rPr>
+              <a:t>→</a:t>
+            </a:r>
+            <a:endParaRPr lang="en-US" sz="2000" dirty="0"/>
+          </a:p>
+        </p:txBody>
+      </p:sp>
+      <p:sp>
+        <p:nvSpPr>
+          <p:cNvPr id="23" name="Shape 21"/>
+          <p:cNvSpPr/>
+          <p:nvPr/>
+        </p:nvSpPr>
+        <p:spPr>
+          <a:xfrm>
+            <a:off x="457200" y="2926080"/>
+            <a:ext cx="2651760" cy="1508760"/>
+          </a:xfrm>
+          <a:prstGeom prst="rect">
+            <a:avLst/>
+          </a:prstGeom>
+          <a:solidFill>
+            <a:srgbClr val="FFFFFF"/>
+          </a:solidFill>
+          <a:ln/>
+          <a:effectLst>
+            <a:outerShdw sx="100000" sy="100000" kx="0" ky="0" algn="bl" rotWithShape="0" blurRad="101600" dist="38100" dir="8100000">
+              <a:srgbClr val="000000">
+                <a:alpha val="25000"/>
+              </a:srgbClr>
+            </a:outerShdw>
+          </a:effectLst>
+        </p:spPr>
+      </p:sp>
+      <p:sp>
+        <p:nvSpPr>
+          <p:cNvPr id="24" name="Shape 22"/>
+          <p:cNvSpPr/>
+          <p:nvPr/>
+        </p:nvSpPr>
+        <p:spPr>
+          <a:xfrm>
+            <a:off x="457200" y="2926080"/>
+            <a:ext cx="64008" cy="1508760"/>
+          </a:xfrm>
+          <a:prstGeom prst="rect">
+            <a:avLst/>
+          </a:prstGeom>
+          <a:solidFill>
+            <a:srgbClr val="ED1C24"/>
+          </a:solidFill>
+          <a:ln/>
+        </p:spPr>
+      </p:sp>
+      <p:sp>
+        <p:nvSpPr>
+          <p:cNvPr id="25" name="Text 23"/>
+          <p:cNvSpPr/>
+          <p:nvPr/>
+        </p:nvSpPr>
+        <p:spPr>
+          <a:xfrm>
+            <a:off x="640080" y="3017520"/>
+            <a:ext cx="2377440" cy="365760"/>
+          </a:xfrm>
+          <a:prstGeom prst="rect">
+            <a:avLst/>
+          </a:prstGeom>
+          <a:noFill/>
+          <a:ln/>
+        </p:spPr>
+        <p:txBody>
+          <a:bodyPr wrap="square" lIns="0" tIns="0" rIns="0" bIns="0" rtlCol="0" anchor="ctr"/>
+          <a:lstStyle/>
+          <a:p>
+            <a:pPr indent="0" marL="0">
+              <a:buNone/>
+            </a:pPr>
+            <a:r>
+              <a:rPr lang="en-US" sz="1300" b="1" dirty="0">
+                <a:solidFill>
+                  <a:srgbClr val="222222"/>
+                </a:solidFill>
+                <a:latin typeface="Calibri" pitchFamily="34" charset="0"/>
+                <a:ea typeface="Calibri" pitchFamily="34" charset="-122"/>
+                <a:cs typeface="Calibri" pitchFamily="34" charset="-120"/>
+              </a:rPr>
+              <a:t>_strip_to_kernel_only</a:t>
+            </a:r>
+            <a:endParaRPr lang="en-US" sz="1300" dirty="0"/>
+          </a:p>
+        </p:txBody>
+      </p:sp>
+      <p:sp>
+        <p:nvSpPr>
+          <p:cNvPr id="26" name="Text 24"/>
+          <p:cNvSpPr/>
+          <p:nvPr/>
+        </p:nvSpPr>
+        <p:spPr>
+          <a:xfrm>
+            <a:off x="640080" y="3429000"/>
+            <a:ext cx="2377440" cy="914400"/>
+          </a:xfrm>
+          <a:prstGeom prst="rect">
+            <a:avLst/>
+          </a:prstGeom>
+          <a:noFill/>
+          <a:ln/>
+        </p:spPr>
+        <p:txBody>
+          <a:bodyPr wrap="square" lIns="0" tIns="0" rIns="0" bIns="0" rtlCol="0" anchor="ctr"/>
+          <a:lstStyle/>
+          <a:p>
+            <a:pPr indent="0" marL="0">
+              <a:buNone/>
+            </a:pPr>
+            <a:r>
+              <a:rPr lang="en-US" sz="1000" dirty="0">
+                <a:solidFill>
+                  <a:srgbClr val="555555"/>
                 </a:solidFill>
                 <a:latin typeface="Calibri Light" pitchFamily="34" charset="0"/>
                 <a:ea typeface="Calibri Light" pitchFamily="34" charset="-122"/>
                 <a:cs typeface="Calibri Light" pitchFamily="34" charset="-120"/>
               </a:rPr>
-              <a:t>Generates HIP</a:t>
-            </a:r>
-            <a:endParaRPr lang="en-US" sz="900" dirty="0"/>
-          </a:p>
-        </p:txBody>
-      </p:sp>
-      <p:sp>
-        <p:nvSpPr>
-          <p:cNvPr id="18" name="Text 16"/>
-          <p:cNvSpPr/>
-          <p:nvPr/>
-        </p:nvSpPr>
-        <p:spPr>
-          <a:xfrm>
-            <a:off x="4594860" y="2286000"/>
-            <a:ext cx="1463040" cy="320040"/>
-          </a:xfrm>
-          <a:prstGeom prst="rect">
-            <a:avLst/>
-          </a:prstGeom>
-          <a:noFill/>
-          <a:ln/>
-        </p:spPr>
-        <p:txBody>
-          <a:bodyPr wrap="square" lIns="0" tIns="0" rIns="0" bIns="0" rtlCol="0" anchor="ctr"/>
-          <a:lstStyle/>
-          <a:p>
-            <a:pPr algn="ctr" indent="0" marL="0">
-              <a:buNone/>
-            </a:pPr>
-            <a:r>
-              <a:rPr lang="en-US" sz="900" dirty="0">
-                <a:solidFill>
-                  <a:srgbClr val="888888"/>
+              <a:t>Pre-processor strips host code → coder sees only kernel functions. Eliminates line offset pollution from preamble.</a:t>
+            </a:r>
+            <a:endParaRPr lang="en-US" sz="1000" dirty="0"/>
+          </a:p>
+        </p:txBody>
+      </p:sp>
+      <p:sp>
+        <p:nvSpPr>
+          <p:cNvPr id="27" name="Shape 25"/>
+          <p:cNvSpPr/>
+          <p:nvPr/>
+        </p:nvSpPr>
+        <p:spPr>
+          <a:xfrm>
+            <a:off x="3291840" y="2926080"/>
+            <a:ext cx="2651760" cy="1508760"/>
+          </a:xfrm>
+          <a:prstGeom prst="rect">
+            <a:avLst/>
+          </a:prstGeom>
+          <a:solidFill>
+            <a:srgbClr val="FFFFFF"/>
+          </a:solidFill>
+          <a:ln/>
+          <a:effectLst>
+            <a:outerShdw sx="100000" sy="100000" kx="0" ky="0" algn="bl" rotWithShape="0" blurRad="101600" dist="38100" dir="8100000">
+              <a:srgbClr val="000000">
+                <a:alpha val="25000"/>
+              </a:srgbClr>
+            </a:outerShdw>
+          </a:effectLst>
+        </p:spPr>
+      </p:sp>
+      <p:sp>
+        <p:nvSpPr>
+          <p:cNvPr id="28" name="Shape 26"/>
+          <p:cNvSpPr/>
+          <p:nvPr/>
+        </p:nvSpPr>
+        <p:spPr>
+          <a:xfrm>
+            <a:off x="3291840" y="2926080"/>
+            <a:ext cx="64008" cy="1508760"/>
+          </a:xfrm>
+          <a:prstGeom prst="rect">
+            <a:avLst/>
+          </a:prstGeom>
+          <a:solidFill>
+            <a:srgbClr val="ED1C24"/>
+          </a:solidFill>
+          <a:ln/>
+        </p:spPr>
+      </p:sp>
+      <p:sp>
+        <p:nvSpPr>
+          <p:cNvPr id="29" name="Text 27"/>
+          <p:cNvSpPr/>
+          <p:nvPr/>
+        </p:nvSpPr>
+        <p:spPr>
+          <a:xfrm>
+            <a:off x="3474720" y="3017520"/>
+            <a:ext cx="2377440" cy="365760"/>
+          </a:xfrm>
+          <a:prstGeom prst="rect">
+            <a:avLst/>
+          </a:prstGeom>
+          <a:noFill/>
+          <a:ln/>
+        </p:spPr>
+        <p:txBody>
+          <a:bodyPr wrap="square" lIns="0" tIns="0" rIns="0" bIns="0" rtlCol="0" anchor="ctr"/>
+          <a:lstStyle/>
+          <a:p>
+            <a:pPr indent="0" marL="0">
+              <a:buNone/>
+            </a:pPr>
+            <a:r>
+              <a:rPr lang="en-US" sz="1300" b="1" dirty="0">
+                <a:solidFill>
+                  <a:srgbClr val="222222"/>
+                </a:solidFill>
+                <a:latin typeface="Calibri" pitchFamily="34" charset="0"/>
+                <a:ea typeface="Calibri" pitchFamily="34" charset="-122"/>
+                <a:cs typeface="Calibri" pitchFamily="34" charset="-120"/>
+              </a:rPr>
+              <a:t>Three-Gate Validation</a:t>
+            </a:r>
+            <a:endParaRPr lang="en-US" sz="1300" dirty="0"/>
+          </a:p>
+        </p:txBody>
+      </p:sp>
+      <p:sp>
+        <p:nvSpPr>
+          <p:cNvPr id="30" name="Text 28"/>
+          <p:cNvSpPr/>
+          <p:nvPr/>
+        </p:nvSpPr>
+        <p:spPr>
+          <a:xfrm>
+            <a:off x="3474720" y="3429000"/>
+            <a:ext cx="2377440" cy="914400"/>
+          </a:xfrm>
+          <a:prstGeom prst="rect">
+            <a:avLst/>
+          </a:prstGeom>
+          <a:noFill/>
+          <a:ln/>
+        </p:spPr>
+        <p:txBody>
+          <a:bodyPr wrap="square" lIns="0" tIns="0" rIns="0" bIns="0" rtlCol="0" anchor="ctr"/>
+          <a:lstStyle/>
+          <a:p>
+            <a:pPr indent="0" marL="0">
+              <a:buNone/>
+            </a:pPr>
+            <a:r>
+              <a:rPr lang="en-US" sz="1000" dirty="0">
+                <a:solidFill>
+                  <a:srgbClr val="555555"/>
                 </a:solidFill>
                 <a:latin typeface="Calibri Light" pitchFamily="34" charset="0"/>
                 <a:ea typeface="Calibri Light" pitchFamily="34" charset="-122"/>
                 <a:cs typeface="Calibri Light" pitchFamily="34" charset="-120"/>
               </a:rPr>
-              <a:t>Validates output</a:t>
-            </a:r>
-            <a:endParaRPr lang="en-US" sz="900" dirty="0"/>
-          </a:p>
-        </p:txBody>
-      </p:sp>
-      <p:sp>
-        <p:nvSpPr>
-          <p:cNvPr id="19" name="Text 17"/>
-          <p:cNvSpPr/>
-          <p:nvPr/>
-        </p:nvSpPr>
-        <p:spPr>
-          <a:xfrm>
-            <a:off x="6286500" y="2286000"/>
-            <a:ext cx="1463040" cy="320040"/>
-          </a:xfrm>
-          <a:prstGeom prst="rect">
-            <a:avLst/>
-          </a:prstGeom>
-          <a:noFill/>
-          <a:ln/>
-        </p:spPr>
-        <p:txBody>
-          <a:bodyPr wrap="square" lIns="0" tIns="0" rIns="0" bIns="0" rtlCol="0" anchor="ctr"/>
-          <a:lstStyle/>
-          <a:p>
-            <a:pPr algn="ctr" indent="0" marL="0">
-              <a:buNone/>
-            </a:pPr>
-            <a:r>
-              <a:rPr lang="en-US" sz="900" dirty="0">
-                <a:solidFill>
-                  <a:srgbClr val="888888"/>
+              <a:t>Lexical (rejects prose) → Structural (braces/symbols) → Semantic (31 tests, &lt;1% FP). Halts bad output before compile.</a:t>
+            </a:r>
+            <a:endParaRPr lang="en-US" sz="1000" dirty="0"/>
+          </a:p>
+        </p:txBody>
+      </p:sp>
+      <p:sp>
+        <p:nvSpPr>
+          <p:cNvPr id="31" name="Shape 29"/>
+          <p:cNvSpPr/>
+          <p:nvPr/>
+        </p:nvSpPr>
+        <p:spPr>
+          <a:xfrm>
+            <a:off x="6126480" y="2926080"/>
+            <a:ext cx="2651760" cy="1508760"/>
+          </a:xfrm>
+          <a:prstGeom prst="rect">
+            <a:avLst/>
+          </a:prstGeom>
+          <a:solidFill>
+            <a:srgbClr val="FFFFFF"/>
+          </a:solidFill>
+          <a:ln/>
+          <a:effectLst>
+            <a:outerShdw sx="100000" sy="100000" kx="0" ky="0" algn="bl" rotWithShape="0" blurRad="101600" dist="38100" dir="8100000">
+              <a:srgbClr val="000000">
+                <a:alpha val="25000"/>
+              </a:srgbClr>
+            </a:outerShdw>
+          </a:effectLst>
+        </p:spPr>
+      </p:sp>
+      <p:sp>
+        <p:nvSpPr>
+          <p:cNvPr id="32" name="Shape 30"/>
+          <p:cNvSpPr/>
+          <p:nvPr/>
+        </p:nvSpPr>
+        <p:spPr>
+          <a:xfrm>
+            <a:off x="6126480" y="2926080"/>
+            <a:ext cx="64008" cy="1508760"/>
+          </a:xfrm>
+          <a:prstGeom prst="rect">
+            <a:avLst/>
+          </a:prstGeom>
+          <a:solidFill>
+            <a:srgbClr val="ED1C24"/>
+          </a:solidFill>
+          <a:ln/>
+        </p:spPr>
+      </p:sp>
+      <p:sp>
+        <p:nvSpPr>
+          <p:cNvPr id="33" name="Text 31"/>
+          <p:cNvSpPr/>
+          <p:nvPr/>
+        </p:nvSpPr>
+        <p:spPr>
+          <a:xfrm>
+            <a:off x="6309360" y="3017520"/>
+            <a:ext cx="2377440" cy="365760"/>
+          </a:xfrm>
+          <a:prstGeom prst="rect">
+            <a:avLst/>
+          </a:prstGeom>
+          <a:noFill/>
+          <a:ln/>
+        </p:spPr>
+        <p:txBody>
+          <a:bodyPr wrap="square" lIns="0" tIns="0" rIns="0" bIns="0" rtlCol="0" anchor="ctr"/>
+          <a:lstStyle/>
+          <a:p>
+            <a:pPr indent="0" marL="0">
+              <a:buNone/>
+            </a:pPr>
+            <a:r>
+              <a:rPr lang="en-US" sz="1300" b="1" dirty="0">
+                <a:solidFill>
+                  <a:srgbClr val="222222"/>
+                </a:solidFill>
+                <a:latin typeface="Calibri" pitchFamily="34" charset="0"/>
+                <a:ea typeface="Calibri" pitchFamily="34" charset="-122"/>
+                <a:cs typeface="Calibri" pitchFamily="34" charset="-120"/>
+              </a:rPr>
+              <a:t>Pattern Memory</a:t>
+            </a:r>
+            <a:endParaRPr lang="en-US" sz="1300" dirty="0"/>
+          </a:p>
+        </p:txBody>
+      </p:sp>
+      <p:sp>
+        <p:nvSpPr>
+          <p:cNvPr id="34" name="Text 32"/>
+          <p:cNvSpPr/>
+          <p:nvPr/>
+        </p:nvSpPr>
+        <p:spPr>
+          <a:xfrm>
+            <a:off x="6309360" y="3429000"/>
+            <a:ext cx="2377440" cy="914400"/>
+          </a:xfrm>
+          <a:prstGeom prst="rect">
+            <a:avLst/>
+          </a:prstGeom>
+          <a:noFill/>
+          <a:ln/>
+        </p:spPr>
+        <p:txBody>
+          <a:bodyPr wrap="square" lIns="0" tIns="0" rIns="0" bIns="0" rtlCol="0" anchor="ctr"/>
+          <a:lstStyle/>
+          <a:p>
+            <a:pPr indent="0" marL="0">
+              <a:buNone/>
+            </a:pPr>
+            <a:r>
+              <a:rPr lang="en-US" sz="1000" dirty="0">
+                <a:solidFill>
+                  <a:srgbClr val="555555"/>
                 </a:solidFill>
                 <a:latin typeface="Calibri Light" pitchFamily="34" charset="0"/>
                 <a:ea typeface="Calibri Light" pitchFamily="34" charset="-122"/>
                 <a:cs typeface="Calibri Light" pitchFamily="34" charset="-120"/>
               </a:rPr>
-              <a:t>Failsafe</a:t>
-            </a:r>
-            <a:endParaRPr lang="en-US" sz="900" dirty="0"/>
-          </a:p>
-        </p:txBody>
-      </p:sp>
-      <p:sp>
-        <p:nvSpPr>
-          <p:cNvPr id="20" name="Text 18"/>
-          <p:cNvSpPr/>
-          <p:nvPr/>
-        </p:nvSpPr>
-        <p:spPr>
-          <a:xfrm>
-            <a:off x="2857500" y="1097280"/>
-            <a:ext cx="228600" cy="1097280"/>
+              <a:t>Trigram index + 0.2ms lookup. Cache hits skip LLM entirely — ~60,000× faster than an LLM call.</a:t>
+            </a:r>
+            <a:endParaRPr lang="en-US" sz="1000" dirty="0"/>
+          </a:p>
+        </p:txBody>
+      </p:sp>
+      <p:sp>
+        <p:nvSpPr>
+          <p:cNvPr id="35" name="Shape 33"/>
+          <p:cNvSpPr/>
+          <p:nvPr/>
+        </p:nvSpPr>
+        <p:spPr>
+          <a:xfrm>
+            <a:off x="0" y="4663440"/>
+            <a:ext cx="9144000" cy="480060"/>
+          </a:xfrm>
+          <a:prstGeom prst="rect">
+            <a:avLst/>
+          </a:prstGeom>
+          <a:solidFill>
+            <a:srgbClr val="1A1A2E"/>
+          </a:solidFill>
+          <a:ln/>
+        </p:spPr>
+      </p:sp>
+      <p:sp>
+        <p:nvSpPr>
+          <p:cNvPr id="36" name="Text 34"/>
+          <p:cNvSpPr/>
+          <p:nvPr/>
+        </p:nvSpPr>
+        <p:spPr>
+          <a:xfrm>
+            <a:off x="457200" y="4709160"/>
+            <a:ext cx="8229600" cy="411480"/>
           </a:xfrm>
           <a:prstGeom prst="rect">
             <a:avLst/>
@@ -4576,218 +5088,15 @@
               <a:buNone/>
             </a:pPr>
             <a:r>
-              <a:rPr lang="en-US" sz="2000" dirty="0">
-                <a:solidFill>
-                  <a:srgbClr val="999999"/>
-                </a:solidFill>
-                <a:latin typeface="Calibri" pitchFamily="34" charset="0"/>
-                <a:ea typeface="Calibri" pitchFamily="34" charset="-122"/>
-                <a:cs typeface="Calibri" pitchFamily="34" charset="-120"/>
-              </a:rPr>
-              <a:t>→</a:t>
-            </a:r>
-            <a:endParaRPr lang="en-US" sz="2000" dirty="0"/>
-          </a:p>
-        </p:txBody>
-      </p:sp>
-      <p:sp>
-        <p:nvSpPr>
-          <p:cNvPr id="21" name="Text 19"/>
-          <p:cNvSpPr/>
-          <p:nvPr/>
-        </p:nvSpPr>
-        <p:spPr>
-          <a:xfrm>
-            <a:off x="4366260" y="1097280"/>
-            <a:ext cx="228600" cy="1097280"/>
-          </a:xfrm>
-          <a:prstGeom prst="rect">
-            <a:avLst/>
-          </a:prstGeom>
-          <a:noFill/>
-          <a:ln/>
-        </p:spPr>
-        <p:txBody>
-          <a:bodyPr wrap="square" lIns="0" tIns="0" rIns="0" bIns="0" rtlCol="0" anchor="ctr"/>
-          <a:lstStyle/>
-          <a:p>
-            <a:pPr algn="ctr" indent="0" marL="0">
-              <a:buNone/>
-            </a:pPr>
-            <a:r>
-              <a:rPr lang="en-US" sz="2000" dirty="0">
-                <a:solidFill>
-                  <a:srgbClr val="999999"/>
-                </a:solidFill>
-                <a:latin typeface="Calibri" pitchFamily="34" charset="0"/>
-                <a:ea typeface="Calibri" pitchFamily="34" charset="-122"/>
-                <a:cs typeface="Calibri" pitchFamily="34" charset="-120"/>
-              </a:rPr>
-              <a:t>→</a:t>
-            </a:r>
-            <a:endParaRPr lang="en-US" sz="2000" dirty="0"/>
-          </a:p>
-        </p:txBody>
-      </p:sp>
-      <p:sp>
-        <p:nvSpPr>
-          <p:cNvPr id="22" name="Text 20"/>
-          <p:cNvSpPr/>
-          <p:nvPr/>
-        </p:nvSpPr>
-        <p:spPr>
-          <a:xfrm>
-            <a:off x="6057900" y="1097280"/>
-            <a:ext cx="228600" cy="1097280"/>
-          </a:xfrm>
-          <a:prstGeom prst="rect">
-            <a:avLst/>
-          </a:prstGeom>
-          <a:noFill/>
-          <a:ln/>
-        </p:spPr>
-        <p:txBody>
-          <a:bodyPr wrap="square" lIns="0" tIns="0" rIns="0" bIns="0" rtlCol="0" anchor="ctr"/>
-          <a:lstStyle/>
-          <a:p>
-            <a:pPr algn="ctr" indent="0" marL="0">
-              <a:buNone/>
-            </a:pPr>
-            <a:r>
-              <a:rPr lang="en-US" sz="2000" dirty="0">
-                <a:solidFill>
-                  <a:srgbClr val="999999"/>
-                </a:solidFill>
-                <a:latin typeface="Calibri" pitchFamily="34" charset="0"/>
-                <a:ea typeface="Calibri" pitchFamily="34" charset="-122"/>
-                <a:cs typeface="Calibri" pitchFamily="34" charset="-120"/>
-              </a:rPr>
-              <a:t>→</a:t>
-            </a:r>
-            <a:endParaRPr lang="en-US" sz="2000" dirty="0"/>
-          </a:p>
-        </p:txBody>
-      </p:sp>
-      <p:sp>
-        <p:nvSpPr>
-          <p:cNvPr id="23" name="Shape 21"/>
-          <p:cNvSpPr/>
-          <p:nvPr/>
-        </p:nvSpPr>
-        <p:spPr>
-          <a:xfrm>
-            <a:off x="457200" y="3017520"/>
-            <a:ext cx="2651760" cy="1463040"/>
-          </a:xfrm>
-          <a:prstGeom prst="rect">
-            <a:avLst/>
-          </a:prstGeom>
-          <a:solidFill>
-            <a:srgbClr val="FFFFFF"/>
-          </a:solidFill>
-          <a:ln/>
-          <a:effectLst>
-            <a:outerShdw sx="100000" sy="100000" kx="0" ky="0" algn="bl" rotWithShape="0" blurRad="101600" dist="38100" dir="8100000">
-              <a:srgbClr val="000000">
-                <a:alpha val="30000"/>
-              </a:srgbClr>
-            </a:outerShdw>
-          </a:effectLst>
-        </p:spPr>
-      </p:sp>
-      <p:sp>
-        <p:nvSpPr>
-          <p:cNvPr id="24" name="Shape 22"/>
-          <p:cNvSpPr/>
-          <p:nvPr/>
-        </p:nvSpPr>
-        <p:spPr>
-          <a:xfrm>
-            <a:off x="457200" y="3017520"/>
-            <a:ext cx="64008" cy="1463040"/>
-          </a:xfrm>
-          <a:prstGeom prst="rect">
-            <a:avLst/>
-          </a:prstGeom>
-          <a:solidFill>
-            <a:srgbClr val="ED1C24"/>
-          </a:solidFill>
-          <a:ln/>
-        </p:spPr>
-      </p:sp>
-      <p:sp>
-        <p:nvSpPr>
-          <p:cNvPr id="25" name="Text 23"/>
-          <p:cNvSpPr/>
-          <p:nvPr/>
-        </p:nvSpPr>
-        <p:spPr>
-          <a:xfrm>
-            <a:off x="640080" y="3108960"/>
-            <a:ext cx="2377440" cy="365760"/>
-          </a:xfrm>
-          <a:prstGeom prst="rect">
-            <a:avLst/>
-          </a:prstGeom>
-          <a:noFill/>
-          <a:ln/>
-        </p:spPr>
-        <p:txBody>
-          <a:bodyPr wrap="square" lIns="0" tIns="0" rIns="0" bIns="0" rtlCol="0" anchor="ctr"/>
-          <a:lstStyle/>
-          <a:p>
-            <a:pPr indent="0" marL="0">
-              <a:buNone/>
-            </a:pPr>
-            <a:r>
-              <a:rPr lang="en-US" sz="1300" b="1" dirty="0">
-                <a:solidFill>
-                  <a:srgbClr val="333333"/>
-                </a:solidFill>
-                <a:latin typeface="Calibri" pitchFamily="34" charset="0"/>
-                <a:ea typeface="Calibri" pitchFamily="34" charset="-122"/>
-                <a:cs typeface="Calibri" pitchFamily="34" charset="-120"/>
-              </a:rPr>
-              <a:t>_strip_to_kernel_only</a:t>
-            </a:r>
-            <a:endParaRPr lang="en-US" sz="1300" dirty="0"/>
-          </a:p>
-        </p:txBody>
-      </p:sp>
-      <p:sp>
-        <p:nvSpPr>
-          <p:cNvPr id="26" name="Text 24"/>
-          <p:cNvSpPr/>
-          <p:nvPr/>
-        </p:nvSpPr>
-        <p:spPr>
-          <a:xfrm>
-            <a:off x="640080" y="3474720"/>
-            <a:ext cx="2377440" cy="822960"/>
-          </a:xfrm>
-          <a:prstGeom prst="rect">
-            <a:avLst/>
-          </a:prstGeom>
-          <a:noFill/>
-          <a:ln/>
-        </p:spPr>
-        <p:txBody>
-          <a:bodyPr wrap="square" lIns="0" tIns="0" rIns="0" bIns="0" rtlCol="0" anchor="ctr"/>
-          <a:lstStyle/>
-          <a:p>
-            <a:pPr indent="0" marL="0">
-              <a:buNone/>
-            </a:pPr>
-            <a:r>
               <a:rPr lang="en-US" sz="1000" dirty="0">
                 <a:solidFill>
-                  <a:srgbClr val="666666"/>
+                  <a:srgbClr val="8899AA"/>
                 </a:solidFill>
                 <a:latin typeface="Calibri Light" pitchFamily="34" charset="0"/>
                 <a:ea typeface="Calibri Light" pitchFamily="34" charset="-122"/>
                 <a:cs typeface="Calibri Light" pitchFamily="34" charset="-120"/>
               </a:rPr>
-              <a:t>Pre-processor strips host code → coder sees only kernel functions. Eliminates line offset pollution from preamble.</a:t>
+              <a:t>All LLMs hosted on AMD hardware via Fireworks AI API • Pipeline runs on CPU (no GPU needed for orchestration)</a:t>
             </a:r>
             <a:endParaRPr lang="en-US" sz="1000" dirty="0"/>
           </a:p>
@@ -4795,322 +5104,13 @@
       </p:sp>
       <p:sp>
         <p:nvSpPr>
-          <p:cNvPr id="27" name="Shape 25"/>
-          <p:cNvSpPr/>
-          <p:nvPr/>
-        </p:nvSpPr>
-        <p:spPr>
-          <a:xfrm>
-            <a:off x="3291840" y="3017520"/>
-            <a:ext cx="2651760" cy="1463040"/>
-          </a:xfrm>
-          <a:prstGeom prst="rect">
-            <a:avLst/>
-          </a:prstGeom>
-          <a:solidFill>
-            <a:srgbClr val="FFFFFF"/>
-          </a:solidFill>
-          <a:ln/>
-          <a:effectLst>
-            <a:outerShdw sx="100000" sy="100000" kx="0" ky="0" algn="bl" rotWithShape="0" blurRad="101600" dist="38100" dir="8100000">
-              <a:srgbClr val="000000">
-                <a:alpha val="30000"/>
-              </a:srgbClr>
-            </a:outerShdw>
-          </a:effectLst>
-        </p:spPr>
-      </p:sp>
-      <p:sp>
-        <p:nvSpPr>
-          <p:cNvPr id="28" name="Shape 26"/>
-          <p:cNvSpPr/>
-          <p:nvPr/>
-        </p:nvSpPr>
-        <p:spPr>
-          <a:xfrm>
-            <a:off x="3291840" y="3017520"/>
-            <a:ext cx="64008" cy="1463040"/>
-          </a:xfrm>
-          <a:prstGeom prst="rect">
-            <a:avLst/>
-          </a:prstGeom>
-          <a:solidFill>
-            <a:srgbClr val="ED1C24"/>
-          </a:solidFill>
-          <a:ln/>
-        </p:spPr>
-      </p:sp>
-      <p:sp>
-        <p:nvSpPr>
-          <p:cNvPr id="29" name="Text 27"/>
-          <p:cNvSpPr/>
-          <p:nvPr/>
-        </p:nvSpPr>
-        <p:spPr>
-          <a:xfrm>
-            <a:off x="3474720" y="3108960"/>
-            <a:ext cx="2377440" cy="365760"/>
-          </a:xfrm>
-          <a:prstGeom prst="rect">
-            <a:avLst/>
-          </a:prstGeom>
-          <a:noFill/>
-          <a:ln/>
-        </p:spPr>
-        <p:txBody>
-          <a:bodyPr wrap="square" lIns="0" tIns="0" rIns="0" bIns="0" rtlCol="0" anchor="ctr"/>
-          <a:lstStyle/>
-          <a:p>
-            <a:pPr indent="0" marL="0">
-              <a:buNone/>
-            </a:pPr>
-            <a:r>
-              <a:rPr lang="en-US" sz="1300" b="1" dirty="0">
-                <a:solidFill>
-                  <a:srgbClr val="333333"/>
-                </a:solidFill>
-                <a:latin typeface="Calibri" pitchFamily="34" charset="0"/>
-                <a:ea typeface="Calibri" pitchFamily="34" charset="-122"/>
-                <a:cs typeface="Calibri" pitchFamily="34" charset="-120"/>
-              </a:rPr>
-              <a:t>Three-Gate Validation</a:t>
-            </a:r>
-            <a:endParaRPr lang="en-US" sz="1300" dirty="0"/>
-          </a:p>
-        </p:txBody>
-      </p:sp>
-      <p:sp>
-        <p:nvSpPr>
-          <p:cNvPr id="30" name="Text 28"/>
-          <p:cNvSpPr/>
-          <p:nvPr/>
-        </p:nvSpPr>
-        <p:spPr>
-          <a:xfrm>
-            <a:off x="3474720" y="3474720"/>
-            <a:ext cx="2377440" cy="822960"/>
-          </a:xfrm>
-          <a:prstGeom prst="rect">
-            <a:avLst/>
-          </a:prstGeom>
-          <a:noFill/>
-          <a:ln/>
-        </p:spPr>
-        <p:txBody>
-          <a:bodyPr wrap="square" lIns="0" tIns="0" rIns="0" bIns="0" rtlCol="0" anchor="ctr"/>
-          <a:lstStyle/>
-          <a:p>
-            <a:pPr indent="0" marL="0">
-              <a:buNone/>
-            </a:pPr>
-            <a:r>
-              <a:rPr lang="en-US" sz="1000" dirty="0">
-                <a:solidFill>
-                  <a:srgbClr val="666666"/>
-                </a:solidFill>
-                <a:latin typeface="Calibri Light" pitchFamily="34" charset="0"/>
-                <a:ea typeface="Calibri Light" pitchFamily="34" charset="-122"/>
-                <a:cs typeface="Calibri Light" pitchFamily="34" charset="-120"/>
-              </a:rPr>
-              <a:t>Lexical (rejects prose) → Structural (braces/symbols) → Semantic (31 tests, &lt;1% FP). Halts bad output before compile.</a:t>
-            </a:r>
-            <a:endParaRPr lang="en-US" sz="1000" dirty="0"/>
-          </a:p>
-        </p:txBody>
-      </p:sp>
-      <p:sp>
-        <p:nvSpPr>
-          <p:cNvPr id="31" name="Shape 29"/>
-          <p:cNvSpPr/>
-          <p:nvPr/>
-        </p:nvSpPr>
-        <p:spPr>
-          <a:xfrm>
-            <a:off x="6126480" y="3017520"/>
-            <a:ext cx="2651760" cy="1463040"/>
-          </a:xfrm>
-          <a:prstGeom prst="rect">
-            <a:avLst/>
-          </a:prstGeom>
-          <a:solidFill>
-            <a:srgbClr val="FFFFFF"/>
-          </a:solidFill>
-          <a:ln/>
-          <a:effectLst>
-            <a:outerShdw sx="100000" sy="100000" kx="0" ky="0" algn="bl" rotWithShape="0" blurRad="101600" dist="38100" dir="8100000">
-              <a:srgbClr val="000000">
-                <a:alpha val="30000"/>
-              </a:srgbClr>
-            </a:outerShdw>
-          </a:effectLst>
-        </p:spPr>
-      </p:sp>
-      <p:sp>
-        <p:nvSpPr>
-          <p:cNvPr id="32" name="Shape 30"/>
-          <p:cNvSpPr/>
-          <p:nvPr/>
-        </p:nvSpPr>
-        <p:spPr>
-          <a:xfrm>
-            <a:off x="6126480" y="3017520"/>
-            <a:ext cx="64008" cy="1463040"/>
-          </a:xfrm>
-          <a:prstGeom prst="rect">
-            <a:avLst/>
-          </a:prstGeom>
-          <a:solidFill>
-            <a:srgbClr val="ED1C24"/>
-          </a:solidFill>
-          <a:ln/>
-        </p:spPr>
-      </p:sp>
-      <p:sp>
-        <p:nvSpPr>
-          <p:cNvPr id="33" name="Text 31"/>
-          <p:cNvSpPr/>
-          <p:nvPr/>
-        </p:nvSpPr>
-        <p:spPr>
-          <a:xfrm>
-            <a:off x="6309360" y="3108960"/>
-            <a:ext cx="2377440" cy="365760"/>
-          </a:xfrm>
-          <a:prstGeom prst="rect">
-            <a:avLst/>
-          </a:prstGeom>
-          <a:noFill/>
-          <a:ln/>
-        </p:spPr>
-        <p:txBody>
-          <a:bodyPr wrap="square" lIns="0" tIns="0" rIns="0" bIns="0" rtlCol="0" anchor="ctr"/>
-          <a:lstStyle/>
-          <a:p>
-            <a:pPr indent="0" marL="0">
-              <a:buNone/>
-            </a:pPr>
-            <a:r>
-              <a:rPr lang="en-US" sz="1300" b="1" dirty="0">
-                <a:solidFill>
-                  <a:srgbClr val="333333"/>
-                </a:solidFill>
-                <a:latin typeface="Calibri" pitchFamily="34" charset="0"/>
-                <a:ea typeface="Calibri" pitchFamily="34" charset="-122"/>
-                <a:cs typeface="Calibri" pitchFamily="34" charset="-120"/>
-              </a:rPr>
-              <a:t>Pattern Memory</a:t>
-            </a:r>
-            <a:endParaRPr lang="en-US" sz="1300" dirty="0"/>
-          </a:p>
-        </p:txBody>
-      </p:sp>
-      <p:sp>
-        <p:nvSpPr>
-          <p:cNvPr id="34" name="Text 32"/>
-          <p:cNvSpPr/>
-          <p:nvPr/>
-        </p:nvSpPr>
-        <p:spPr>
-          <a:xfrm>
-            <a:off x="6309360" y="3474720"/>
-            <a:ext cx="2377440" cy="822960"/>
-          </a:xfrm>
-          <a:prstGeom prst="rect">
-            <a:avLst/>
-          </a:prstGeom>
-          <a:noFill/>
-          <a:ln/>
-        </p:spPr>
-        <p:txBody>
-          <a:bodyPr wrap="square" lIns="0" tIns="0" rIns="0" bIns="0" rtlCol="0" anchor="ctr"/>
-          <a:lstStyle/>
-          <a:p>
-            <a:pPr indent="0" marL="0">
-              <a:buNone/>
-            </a:pPr>
-            <a:r>
-              <a:rPr lang="en-US" sz="1000" dirty="0">
-                <a:solidFill>
-                  <a:srgbClr val="666666"/>
-                </a:solidFill>
-                <a:latin typeface="Calibri Light" pitchFamily="34" charset="0"/>
-                <a:ea typeface="Calibri Light" pitchFamily="34" charset="-122"/>
-                <a:cs typeface="Calibri Light" pitchFamily="34" charset="-120"/>
-              </a:rPr>
-              <a:t>Trigram index + 0.2ms lookup. Cache hits skip LLM entirely — ~60,000× faster than an LLM call.</a:t>
-            </a:r>
-            <a:endParaRPr lang="en-US" sz="1000" dirty="0"/>
-          </a:p>
-        </p:txBody>
-      </p:sp>
-      <p:sp>
-        <p:nvSpPr>
-          <p:cNvPr id="35" name="Shape 33"/>
-          <p:cNvSpPr/>
-          <p:nvPr/>
-        </p:nvSpPr>
-        <p:spPr>
-          <a:xfrm>
-            <a:off x="0" y="4663440"/>
-            <a:ext cx="9144000" cy="480060"/>
-          </a:xfrm>
-          <a:prstGeom prst="rect">
-            <a:avLst/>
-          </a:prstGeom>
-          <a:solidFill>
-            <a:srgbClr val="1A1A2E"/>
-          </a:solidFill>
-          <a:ln/>
-        </p:spPr>
-      </p:sp>
-      <p:sp>
-        <p:nvSpPr>
-          <p:cNvPr id="36" name="Text 34"/>
-          <p:cNvSpPr/>
-          <p:nvPr/>
-        </p:nvSpPr>
-        <p:spPr>
-          <a:xfrm>
-            <a:off x="457200" y="4709160"/>
-            <a:ext cx="8229600" cy="411480"/>
-          </a:xfrm>
-          <a:prstGeom prst="rect">
-            <a:avLst/>
-          </a:prstGeom>
-          <a:noFill/>
-          <a:ln/>
-        </p:spPr>
-        <p:txBody>
-          <a:bodyPr wrap="square" lIns="0" tIns="0" rIns="0" bIns="0" rtlCol="0" anchor="ctr"/>
-          <a:lstStyle/>
-          <a:p>
-            <a:pPr algn="ctr" indent="0" marL="0">
-              <a:buNone/>
-            </a:pPr>
-            <a:r>
-              <a:rPr lang="en-US" sz="1000" dirty="0">
-                <a:solidFill>
-                  <a:srgbClr val="8899AA"/>
-                </a:solidFill>
-                <a:latin typeface="Calibri Light" pitchFamily="34" charset="0"/>
-                <a:ea typeface="Calibri Light" pitchFamily="34" charset="-122"/>
-                <a:cs typeface="Calibri Light" pitchFamily="34" charset="-120"/>
-              </a:rPr>
-              <a:t>All LLMs hosted on AMD hardware via Fireworks AI API • Runs on CPU (no GPU needed for pipeline)</a:t>
-            </a:r>
-            <a:endParaRPr lang="en-US" sz="1000" dirty="0"/>
-          </a:p>
-        </p:txBody>
-      </p:sp>
-      <p:sp>
-        <p:nvSpPr>
           <p:cNvPr id="37" name="Text 35"/>
           <p:cNvSpPr/>
           <p:nvPr/>
         </p:nvSpPr>
         <p:spPr>
           <a:xfrm>
-            <a:off x="7772400" y="4572000"/>
+            <a:off x="7772400" y="4754880"/>
             <a:ext cx="1097280" cy="320040"/>
           </a:xfrm>
           <a:prstGeom prst="rect">
@@ -5265,7 +5265,7 @@
                 <a:ea typeface="Calibri" pitchFamily="34" charset="-122"/>
                 <a:cs typeface="Calibri" pitchFamily="34" charset="-120"/>
               </a:rPr>
-              <a:t>❌  Before (full CUDA source → coder)</a:t>
+              <a:t>Before (full CUDA source → coder)</a:t>
             </a:r>
             <a:endParaRPr lang="en-US" sz="1300" dirty="0"/>
           </a:p>
@@ -5280,7 +5280,7 @@
         <p:spPr>
           <a:xfrm>
             <a:off x="457200" y="1280160"/>
-            <a:ext cx="3931920" cy="2926080"/>
+            <a:ext cx="3931920" cy="2743200"/>
           </a:xfrm>
           <a:prstGeom prst="rect">
             <a:avLst/>
@@ -5292,7 +5292,7 @@
           <a:effectLst>
             <a:outerShdw sx="100000" sy="100000" kx="0" ky="0" algn="bl" rotWithShape="0" blurRad="101600" dist="38100" dir="8100000">
               <a:srgbClr val="000000">
-                <a:alpha val="30000"/>
+                <a:alpha val="25000"/>
               </a:srgbClr>
             </a:outerShdw>
           </a:effectLst>
@@ -5307,7 +5307,7 @@
         <p:spPr>
           <a:xfrm>
             <a:off x="640080" y="1371600"/>
-            <a:ext cx="3566160" cy="2651760"/>
+            <a:ext cx="3566160" cy="2468880"/>
           </a:xfrm>
           <a:prstGeom prst="rect">
             <a:avLst/>
@@ -5331,7 +5331,7 @@
                 <a:ea typeface="Consolas" pitchFamily="34" charset="-122"/>
                 <a:cs typeface="Consolas" pitchFamily="34" charset="-120"/>
               </a:rPr>
-              <a:t>// Copyright (c) 2024 NVIDIA Corporation</a:t>
+              <a:t>// Copyright (c) 2024 NVIDIA Corp</a:t>
             </a:r>
             <a:endParaRPr lang="en-US" sz="900" dirty="0"/>
           </a:p>
@@ -5379,6 +5379,12 @@
             <a:pPr indent="0" marL="0">
               <a:buNone/>
             </a:pPr>
+            <a:endParaRPr lang="en-US" sz="900" dirty="0"/>
+          </a:p>
+          <a:p>
+            <a:pPr indent="0" marL="0">
+              <a:buNone/>
+            </a:pPr>
             <a:r>
               <a:rPr lang="en-US" sz="900" dirty="0">
                 <a:solidFill>
@@ -5388,14 +5394,8 @@
                 <a:ea typeface="Consolas" pitchFamily="34" charset="-122"/>
                 <a:cs typeface="Consolas" pitchFamily="34" charset="-120"/>
               </a:rPr>
-              <a:t>#include &lt;cuda.h&gt;</a:t>
-            </a:r>
-            <a:endParaRPr lang="en-US" sz="900" dirty="0"/>
-          </a:p>
-          <a:p>
-            <a:pPr indent="0" marL="0">
-              <a:buNone/>
-            </a:pPr>
+              <a:t>__host__ void init() {</a:t>
+            </a:r>
             <a:endParaRPr lang="en-US" sz="900" dirty="0"/>
           </a:p>
           <a:p>
@@ -5411,7 +5411,7 @@
                 <a:ea typeface="Consolas" pitchFamily="34" charset="-122"/>
                 <a:cs typeface="Consolas" pitchFamily="34" charset="-120"/>
               </a:rPr>
-              <a:t>__host__ void init() {</a:t>
+              <a:t>  cudaSetDevice(0);</a:t>
             </a:r>
             <a:endParaRPr lang="en-US" sz="900" dirty="0"/>
           </a:p>
@@ -5428,8 +5428,14 @@
                 <a:ea typeface="Consolas" pitchFamily="34" charset="-122"/>
                 <a:cs typeface="Consolas" pitchFamily="34" charset="-120"/>
               </a:rPr>
-              <a:t>  cudaSetDevice(0);</a:t>
-            </a:r>
+              <a:t>}</a:t>
+            </a:r>
+            <a:endParaRPr lang="en-US" sz="900" dirty="0"/>
+          </a:p>
+          <a:p>
+            <a:pPr indent="0" marL="0">
+              <a:buNone/>
+            </a:pPr>
             <a:endParaRPr lang="en-US" sz="900" dirty="0"/>
           </a:p>
           <a:p>
@@ -5445,14 +5451,8 @@
                 <a:ea typeface="Consolas" pitchFamily="34" charset="-122"/>
                 <a:cs typeface="Consolas" pitchFamily="34" charset="-120"/>
               </a:rPr>
-              <a:t>}</a:t>
-            </a:r>
-            <a:endParaRPr lang="en-US" sz="900" dirty="0"/>
-          </a:p>
-          <a:p>
-            <a:pPr indent="0" marL="0">
-              <a:buNone/>
-            </a:pPr>
+              <a:t>__global__ void kernel() {</a:t>
+            </a:r>
             <a:endParaRPr lang="en-US" sz="900" dirty="0"/>
           </a:p>
           <a:p>
@@ -5468,7 +5468,7 @@
                 <a:ea typeface="Consolas" pitchFamily="34" charset="-122"/>
                 <a:cs typeface="Consolas" pitchFamily="34" charset="-120"/>
               </a:rPr>
-              <a:t>__global__ void kernel() {</a:t>
+              <a:t>  int tid = threadIdx.x;</a:t>
             </a:r>
             <a:endParaRPr lang="en-US" sz="900" dirty="0"/>
           </a:p>
@@ -5485,7 +5485,7 @@
                 <a:ea typeface="Consolas" pitchFamily="34" charset="-122"/>
                 <a:cs typeface="Consolas" pitchFamily="34" charset="-120"/>
               </a:rPr>
-              <a:t>  int tid = threadIdx.x;</a:t>
+              <a:t>  __syncthreads();</a:t>
             </a:r>
             <a:endParaRPr lang="en-US" sz="900" dirty="0"/>
           </a:p>
@@ -5502,8 +5502,14 @@
                 <a:ea typeface="Consolas" pitchFamily="34" charset="-122"/>
                 <a:cs typeface="Consolas" pitchFamily="34" charset="-120"/>
               </a:rPr>
-              <a:t>  __syncthreads();</a:t>
-            </a:r>
+              <a:t>}</a:t>
+            </a:r>
+            <a:endParaRPr lang="en-US" sz="900" dirty="0"/>
+          </a:p>
+          <a:p>
+            <a:pPr indent="0" marL="0">
+              <a:buNone/>
+            </a:pPr>
             <a:endParaRPr lang="en-US" sz="900" dirty="0"/>
           </a:p>
           <a:p>
@@ -5519,14 +5525,8 @@
                 <a:ea typeface="Consolas" pitchFamily="34" charset="-122"/>
                 <a:cs typeface="Consolas" pitchFamily="34" charset="-120"/>
               </a:rPr>
-              <a:t>}</a:t>
-            </a:r>
-            <a:endParaRPr lang="en-US" sz="900" dirty="0"/>
-          </a:p>
-          <a:p>
-            <a:pPr indent="0" marL="0">
-              <a:buNone/>
-            </a:pPr>
+              <a:t>int main() {</a:t>
+            </a:r>
             <a:endParaRPr lang="en-US" sz="900" dirty="0"/>
           </a:p>
           <a:p>
@@ -5542,7 +5542,7 @@
                 <a:ea typeface="Consolas" pitchFamily="34" charset="-122"/>
                 <a:cs typeface="Consolas" pitchFamily="34" charset="-120"/>
               </a:rPr>
-              <a:t>int main() {</a:t>
+              <a:t>  init&lt;&lt;&lt;1, 32&gt;&gt;&gt;();</a:t>
             </a:r>
             <a:endParaRPr lang="en-US" sz="900" dirty="0"/>
           </a:p>
@@ -5559,7 +5559,7 @@
                 <a:ea typeface="Consolas" pitchFamily="34" charset="-122"/>
                 <a:cs typeface="Consolas" pitchFamily="34" charset="-120"/>
               </a:rPr>
-              <a:t>  init&lt;&lt;&lt;1, 32&gt;&gt;&gt;();</a:t>
+              <a:t>  return 0;</a:t>
             </a:r>
             <a:endParaRPr lang="en-US" sz="900" dirty="0"/>
           </a:p>
@@ -5576,10 +5576,137 @@
                 <a:ea typeface="Consolas" pitchFamily="34" charset="-122"/>
                 <a:cs typeface="Consolas" pitchFamily="34" charset="-120"/>
               </a:rPr>
-              <a:t>  return 0;</a:t>
+              <a:t>}</a:t>
             </a:r>
             <a:endParaRPr lang="en-US" sz="900" dirty="0"/>
           </a:p>
+        </p:txBody>
+      </p:sp>
+      <p:sp>
+        <p:nvSpPr>
+          <p:cNvPr id="7" name="Text 5"/>
+          <p:cNvSpPr/>
+          <p:nvPr/>
+        </p:nvSpPr>
+        <p:spPr>
+          <a:xfrm>
+            <a:off x="457200" y="4069080"/>
+            <a:ext cx="3931920" cy="274320"/>
+          </a:xfrm>
+          <a:prstGeom prst="rect">
+            <a:avLst/>
+          </a:prstGeom>
+          <a:noFill/>
+          <a:ln/>
+        </p:spPr>
+        <p:txBody>
+          <a:bodyPr wrap="square" lIns="0" tIns="0" rIns="0" bIns="0" rtlCol="0" anchor="ctr"/>
+          <a:lstStyle/>
+          <a:p>
+            <a:pPr algn="ctr" indent="0" marL="0">
+              <a:buNone/>
+            </a:pPr>
+            <a:r>
+              <a:rPr lang="en-US" sz="1000" dirty="0">
+                <a:solidFill>
+                  <a:srgbClr val="E94560"/>
+                </a:solidFill>
+                <a:latin typeface="Calibri Light" pitchFamily="34" charset="0"/>
+                <a:ea typeface="Calibri Light" pitchFamily="34" charset="-122"/>
+                <a:cs typeface="Calibri Light" pitchFamily="34" charset="-120"/>
+              </a:rPr>
+              <a:t>30-line preamble → line offset pollution → false compile errors</a:t>
+            </a:r>
+            <a:endParaRPr lang="en-US" sz="1000" dirty="0"/>
+          </a:p>
+        </p:txBody>
+      </p:sp>
+      <p:sp>
+        <p:nvSpPr>
+          <p:cNvPr id="8" name="Text 6"/>
+          <p:cNvSpPr/>
+          <p:nvPr/>
+        </p:nvSpPr>
+        <p:spPr>
+          <a:xfrm>
+            <a:off x="4754880" y="914400"/>
+            <a:ext cx="3931920" cy="365760"/>
+          </a:xfrm>
+          <a:prstGeom prst="rect">
+            <a:avLst/>
+          </a:prstGeom>
+          <a:noFill/>
+          <a:ln/>
+        </p:spPr>
+        <p:txBody>
+          <a:bodyPr wrap="square" lIns="0" tIns="0" rIns="0" bIns="0" rtlCol="0" anchor="ctr"/>
+          <a:lstStyle/>
+          <a:p>
+            <a:pPr indent="0" marL="0">
+              <a:buNone/>
+            </a:pPr>
+            <a:r>
+              <a:rPr lang="en-US" sz="1300" b="1" dirty="0">
+                <a:solidFill>
+                  <a:srgbClr val="4ECB71"/>
+                </a:solidFill>
+                <a:latin typeface="Calibri" pitchFamily="34" charset="0"/>
+                <a:ea typeface="Calibri" pitchFamily="34" charset="-122"/>
+                <a:cs typeface="Calibri" pitchFamily="34" charset="-120"/>
+              </a:rPr>
+              <a:t>After (kernel-only → coder)</a:t>
+            </a:r>
+            <a:endParaRPr lang="en-US" sz="1300" dirty="0"/>
+          </a:p>
+        </p:txBody>
+      </p:sp>
+      <p:sp>
+        <p:nvSpPr>
+          <p:cNvPr id="9" name="Shape 7"/>
+          <p:cNvSpPr/>
+          <p:nvPr/>
+        </p:nvSpPr>
+        <p:spPr>
+          <a:xfrm>
+            <a:off x="4754880" y="1280160"/>
+            <a:ext cx="3931920" cy="2743200"/>
+          </a:xfrm>
+          <a:prstGeom prst="rect">
+            <a:avLst/>
+          </a:prstGeom>
+          <a:solidFill>
+            <a:srgbClr val="1A1A30"/>
+          </a:solidFill>
+          <a:ln/>
+          <a:effectLst>
+            <a:outerShdw sx="100000" sy="100000" kx="0" ky="0" algn="bl" rotWithShape="0" blurRad="101600" dist="38100" dir="8100000">
+              <a:srgbClr val="000000">
+                <a:alpha val="25000"/>
+              </a:srgbClr>
+            </a:outerShdw>
+          </a:effectLst>
+        </p:spPr>
+      </p:sp>
+      <p:sp>
+        <p:nvSpPr>
+          <p:cNvPr id="10" name="Text 8"/>
+          <p:cNvSpPr/>
+          <p:nvPr/>
+        </p:nvSpPr>
+        <p:spPr>
+          <a:xfrm>
+            <a:off x="4937760" y="1371600"/>
+            <a:ext cx="3566160" cy="1828800"/>
+          </a:xfrm>
+          <a:prstGeom prst="rect">
+            <a:avLst/>
+          </a:prstGeom>
+          <a:noFill/>
+          <a:ln/>
+        </p:spPr>
+        <p:txBody>
+          <a:bodyPr wrap="square" lIns="0" tIns="0" rIns="0" bIns="0" rtlCol="0" anchor="ctr"/>
+          <a:lstStyle/>
           <a:p>
             <a:pPr indent="0" marL="0">
               <a:buNone/>
@@ -5593,6 +5720,57 @@
                 <a:ea typeface="Consolas" pitchFamily="34" charset="-122"/>
                 <a:cs typeface="Consolas" pitchFamily="34" charset="-120"/>
               </a:rPr>
+              <a:t>__global__ void kernel() {</a:t>
+            </a:r>
+            <a:endParaRPr lang="en-US" sz="900" dirty="0"/>
+          </a:p>
+          <a:p>
+            <a:pPr indent="0" marL="0">
+              <a:buNone/>
+            </a:pPr>
+            <a:r>
+              <a:rPr lang="en-US" sz="900" dirty="0">
+                <a:solidFill>
+                  <a:srgbClr val="CCCCCC"/>
+                </a:solidFill>
+                <a:latin typeface="Consolas" pitchFamily="34" charset="0"/>
+                <a:ea typeface="Consolas" pitchFamily="34" charset="-122"/>
+                <a:cs typeface="Consolas" pitchFamily="34" charset="-120"/>
+              </a:rPr>
+              <a:t>  int tid = threadIdx.x;</a:t>
+            </a:r>
+            <a:endParaRPr lang="en-US" sz="900" dirty="0"/>
+          </a:p>
+          <a:p>
+            <a:pPr indent="0" marL="0">
+              <a:buNone/>
+            </a:pPr>
+            <a:r>
+              <a:rPr lang="en-US" sz="900" dirty="0">
+                <a:solidFill>
+                  <a:srgbClr val="CCCCCC"/>
+                </a:solidFill>
+                <a:latin typeface="Consolas" pitchFamily="34" charset="0"/>
+                <a:ea typeface="Consolas" pitchFamily="34" charset="-122"/>
+                <a:cs typeface="Consolas" pitchFamily="34" charset="-120"/>
+              </a:rPr>
+              <a:t>  __syncthreads();</a:t>
+            </a:r>
+            <a:endParaRPr lang="en-US" sz="900" dirty="0"/>
+          </a:p>
+          <a:p>
+            <a:pPr indent="0" marL="0">
+              <a:buNone/>
+            </a:pPr>
+            <a:r>
+              <a:rPr lang="en-US" sz="900" dirty="0">
+                <a:solidFill>
+                  <a:srgbClr val="CCCCCC"/>
+                </a:solidFill>
+                <a:latin typeface="Consolas" pitchFamily="34" charset="0"/>
+                <a:ea typeface="Consolas" pitchFamily="34" charset="-122"/>
+                <a:cs typeface="Consolas" pitchFamily="34" charset="-120"/>
+              </a:rPr>
               <a:t>}</a:t>
             </a:r>
             <a:endParaRPr lang="en-US" sz="900" dirty="0"/>
@@ -5601,13 +5779,13 @@
       </p:sp>
       <p:sp>
         <p:nvSpPr>
-          <p:cNvPr id="7" name="Text 5"/>
-          <p:cNvSpPr/>
-          <p:nvPr/>
-        </p:nvSpPr>
-        <p:spPr>
-          <a:xfrm>
-            <a:off x="457200" y="4206240"/>
+          <p:cNvPr id="11" name="Text 9"/>
+          <p:cNvSpPr/>
+          <p:nvPr/>
+        </p:nvSpPr>
+        <p:spPr>
+          <a:xfrm>
+            <a:off x="4754880" y="4069080"/>
             <a:ext cx="3931920" cy="274320"/>
           </a:xfrm>
           <a:prstGeom prst="rect">
@@ -5626,13 +5804,13 @@
             <a:r>
               <a:rPr lang="en-US" sz="1000" dirty="0">
                 <a:solidFill>
-                  <a:srgbClr val="E94560"/>
+                  <a:srgbClr val="4ECB71"/>
                 </a:solidFill>
                 <a:latin typeface="Calibri Light" pitchFamily="34" charset="0"/>
                 <a:ea typeface="Calibri Light" pitchFamily="34" charset="-122"/>
                 <a:cs typeface="Calibri Light" pitchFamily="34" charset="-120"/>
               </a:rPr>
-              <a:t>⚠️ 30-line preamble → line offset pollution → false compile errors</a:t>
+              <a:t>Strips includes, host code, main() — coder sees ONLY kernel bodies</a:t>
             </a:r>
             <a:endParaRPr lang="en-US" sz="1000" dirty="0"/>
           </a:p>
@@ -5640,232 +5818,37 @@
       </p:sp>
       <p:sp>
         <p:nvSpPr>
-          <p:cNvPr id="8" name="Text 6"/>
-          <p:cNvSpPr/>
-          <p:nvPr/>
-        </p:nvSpPr>
-        <p:spPr>
-          <a:xfrm>
-            <a:off x="4754880" y="914400"/>
-            <a:ext cx="3931920" cy="365760"/>
-          </a:xfrm>
-          <a:prstGeom prst="rect">
-            <a:avLst/>
-          </a:prstGeom>
-          <a:noFill/>
-          <a:ln/>
-        </p:spPr>
-        <p:txBody>
-          <a:bodyPr wrap="square" lIns="0" tIns="0" rIns="0" bIns="0" rtlCol="0" anchor="ctr"/>
-          <a:lstStyle/>
-          <a:p>
-            <a:pPr indent="0" marL="0">
-              <a:buNone/>
-            </a:pPr>
-            <a:r>
-              <a:rPr lang="en-US" sz="1300" b="1" dirty="0">
-                <a:solidFill>
-                  <a:srgbClr val="4ECB71"/>
+          <p:cNvPr id="12" name="Text 10"/>
+          <p:cNvSpPr/>
+          <p:nvPr/>
+        </p:nvSpPr>
+        <p:spPr>
+          <a:xfrm>
+            <a:off x="457200" y="4572000"/>
+            <a:ext cx="8229600" cy="320040"/>
+          </a:xfrm>
+          <a:prstGeom prst="rect">
+            <a:avLst/>
+          </a:prstGeom>
+          <a:noFill/>
+          <a:ln/>
+        </p:spPr>
+        <p:txBody>
+          <a:bodyPr wrap="square" lIns="0" tIns="0" rIns="0" bIns="0" rtlCol="0" anchor="ctr"/>
+          <a:lstStyle/>
+          <a:p>
+            <a:pPr algn="ctr" indent="0" marL="0">
+              <a:buNone/>
+            </a:pPr>
+            <a:r>
+              <a:rPr lang="en-US" sz="1100" dirty="0">
+                <a:solidFill>
+                  <a:srgbClr val="8899AA"/>
                 </a:solidFill>
                 <a:latin typeface="Calibri" pitchFamily="34" charset="0"/>
                 <a:ea typeface="Calibri" pitchFamily="34" charset="-122"/>
                 <a:cs typeface="Calibri" pitchFamily="34" charset="-120"/>
               </a:rPr>
-              <a:t>✅  After (kernel-only → coder)</a:t>
-            </a:r>
-            <a:endParaRPr lang="en-US" sz="1300" dirty="0"/>
-          </a:p>
-        </p:txBody>
-      </p:sp>
-      <p:sp>
-        <p:nvSpPr>
-          <p:cNvPr id="9" name="Shape 7"/>
-          <p:cNvSpPr/>
-          <p:nvPr/>
-        </p:nvSpPr>
-        <p:spPr>
-          <a:xfrm>
-            <a:off x="4754880" y="1280160"/>
-            <a:ext cx="3931920" cy="2926080"/>
-          </a:xfrm>
-          <a:prstGeom prst="rect">
-            <a:avLst/>
-          </a:prstGeom>
-          <a:solidFill>
-            <a:srgbClr val="1A1A30"/>
-          </a:solidFill>
-          <a:ln/>
-          <a:effectLst>
-            <a:outerShdw sx="100000" sy="100000" kx="0" ky="0" algn="bl" rotWithShape="0" blurRad="101600" dist="38100" dir="8100000">
-              <a:srgbClr val="000000">
-                <a:alpha val="30000"/>
-              </a:srgbClr>
-            </a:outerShdw>
-          </a:effectLst>
-        </p:spPr>
-      </p:sp>
-      <p:sp>
-        <p:nvSpPr>
-          <p:cNvPr id="10" name="Text 8"/>
-          <p:cNvSpPr/>
-          <p:nvPr/>
-        </p:nvSpPr>
-        <p:spPr>
-          <a:xfrm>
-            <a:off x="4937760" y="1371600"/>
-            <a:ext cx="3566160" cy="2011680"/>
-          </a:xfrm>
-          <a:prstGeom prst="rect">
-            <a:avLst/>
-          </a:prstGeom>
-          <a:noFill/>
-          <a:ln/>
-        </p:spPr>
-        <p:txBody>
-          <a:bodyPr wrap="square" lIns="0" tIns="0" rIns="0" bIns="0" rtlCol="0" anchor="ctr"/>
-          <a:lstStyle/>
-          <a:p>
-            <a:pPr indent="0" marL="0">
-              <a:buNone/>
-            </a:pPr>
-            <a:r>
-              <a:rPr lang="en-US" sz="900" dirty="0">
-                <a:solidFill>
-                  <a:srgbClr val="CCCCCC"/>
-                </a:solidFill>
-                <a:latin typeface="Consolas" pitchFamily="34" charset="0"/>
-                <a:ea typeface="Consolas" pitchFamily="34" charset="-122"/>
-                <a:cs typeface="Consolas" pitchFamily="34" charset="-120"/>
-              </a:rPr>
-              <a:t>__global__ void kernel() {</a:t>
-            </a:r>
-            <a:endParaRPr lang="en-US" sz="900" dirty="0"/>
-          </a:p>
-          <a:p>
-            <a:pPr indent="0" marL="0">
-              <a:buNone/>
-            </a:pPr>
-            <a:r>
-              <a:rPr lang="en-US" sz="900" dirty="0">
-                <a:solidFill>
-                  <a:srgbClr val="CCCCCC"/>
-                </a:solidFill>
-                <a:latin typeface="Consolas" pitchFamily="34" charset="0"/>
-                <a:ea typeface="Consolas" pitchFamily="34" charset="-122"/>
-                <a:cs typeface="Consolas" pitchFamily="34" charset="-120"/>
-              </a:rPr>
-              <a:t>  int tid = threadIdx.x;</a:t>
-            </a:r>
-            <a:endParaRPr lang="en-US" sz="900" dirty="0"/>
-          </a:p>
-          <a:p>
-            <a:pPr indent="0" marL="0">
-              <a:buNone/>
-            </a:pPr>
-            <a:r>
-              <a:rPr lang="en-US" sz="900" dirty="0">
-                <a:solidFill>
-                  <a:srgbClr val="CCCCCC"/>
-                </a:solidFill>
-                <a:latin typeface="Consolas" pitchFamily="34" charset="0"/>
-                <a:ea typeface="Consolas" pitchFamily="34" charset="-122"/>
-                <a:cs typeface="Consolas" pitchFamily="34" charset="-120"/>
-              </a:rPr>
-              <a:t>  __syncthreads();</a:t>
-            </a:r>
-            <a:endParaRPr lang="en-US" sz="900" dirty="0"/>
-          </a:p>
-          <a:p>
-            <a:pPr indent="0" marL="0">
-              <a:buNone/>
-            </a:pPr>
-            <a:r>
-              <a:rPr lang="en-US" sz="900" dirty="0">
-                <a:solidFill>
-                  <a:srgbClr val="CCCCCC"/>
-                </a:solidFill>
-                <a:latin typeface="Consolas" pitchFamily="34" charset="0"/>
-                <a:ea typeface="Consolas" pitchFamily="34" charset="-122"/>
-                <a:cs typeface="Consolas" pitchFamily="34" charset="-120"/>
-              </a:rPr>
-              <a:t>}</a:t>
-            </a:r>
-            <a:endParaRPr lang="en-US" sz="900" dirty="0"/>
-          </a:p>
-        </p:txBody>
-      </p:sp>
-      <p:sp>
-        <p:nvSpPr>
-          <p:cNvPr id="11" name="Text 9"/>
-          <p:cNvSpPr/>
-          <p:nvPr/>
-        </p:nvSpPr>
-        <p:spPr>
-          <a:xfrm>
-            <a:off x="4754880" y="4206240"/>
-            <a:ext cx="3931920" cy="274320"/>
-          </a:xfrm>
-          <a:prstGeom prst="rect">
-            <a:avLst/>
-          </a:prstGeom>
-          <a:noFill/>
-          <a:ln/>
-        </p:spPr>
-        <p:txBody>
-          <a:bodyPr wrap="square" lIns="0" tIns="0" rIns="0" bIns="0" rtlCol="0" anchor="ctr"/>
-          <a:lstStyle/>
-          <a:p>
-            <a:pPr algn="ctr" indent="0" marL="0">
-              <a:buNone/>
-            </a:pPr>
-            <a:r>
-              <a:rPr lang="en-US" sz="1000" dirty="0">
-                <a:solidFill>
-                  <a:srgbClr val="4ECB71"/>
-                </a:solidFill>
-                <a:latin typeface="Calibri Light" pitchFamily="34" charset="0"/>
-                <a:ea typeface="Calibri Light" pitchFamily="34" charset="-122"/>
-                <a:cs typeface="Calibri Light" pitchFamily="34" charset="-120"/>
-              </a:rPr>
-              <a:t>✓ Strips includes, host code, main() — coder sees ONLY kernel bodies</a:t>
-            </a:r>
-            <a:endParaRPr lang="en-US" sz="1000" dirty="0"/>
-          </a:p>
-        </p:txBody>
-      </p:sp>
-      <p:sp>
-        <p:nvSpPr>
-          <p:cNvPr id="12" name="Text 10"/>
-          <p:cNvSpPr/>
-          <p:nvPr/>
-        </p:nvSpPr>
-        <p:spPr>
-          <a:xfrm>
-            <a:off x="457200" y="4709160"/>
-            <a:ext cx="8229600" cy="320040"/>
-          </a:xfrm>
-          <a:prstGeom prst="rect">
-            <a:avLst/>
-          </a:prstGeom>
-          <a:noFill/>
-          <a:ln/>
-        </p:spPr>
-        <p:txBody>
-          <a:bodyPr wrap="square" lIns="0" tIns="0" rIns="0" bIns="0" rtlCol="0" anchor="ctr"/>
-          <a:lstStyle/>
-          <a:p>
-            <a:pPr algn="ctr" indent="0" marL="0">
-              <a:buNone/>
-            </a:pPr>
-            <a:r>
-              <a:rPr lang="en-US" sz="1100" dirty="0">
-                <a:solidFill>
-                  <a:srgbClr val="8899AA"/>
-                </a:solidFill>
-                <a:latin typeface="Calibri" pitchFamily="34" charset="0"/>
-                <a:ea typeface="Calibri" pitchFamily="34" charset="-122"/>
-                <a:cs typeface="Calibri" pitchFamily="34" charset="-120"/>
-              </a:rPr>
               <a:t>Result: Precise line offsets → reliable HIP output → fewer retries → 2x faster pipeline</a:t>
             </a:r>
             <a:endParaRPr lang="en-US" sz="1100" dirty="0"/>
@@ -5880,7 +5863,7 @@
         </p:nvSpPr>
         <p:spPr>
           <a:xfrm>
-            <a:off x="7772400" y="4572000"/>
+            <a:off x="7772400" y="4754880"/>
             <a:ext cx="1097280" cy="320040"/>
           </a:xfrm>
           <a:prstGeom prst="rect">
@@ -5990,7 +5973,7 @@
             <a:r>
               <a:rPr lang="en-US" sz="2200" b="1" dirty="0">
                 <a:solidFill>
-                  <a:srgbClr val="FFFFFF"/>
+                  <a:srgbClr val="222222"/>
                 </a:solidFill>
                 <a:latin typeface="Calibri" pitchFamily="34" charset="0"/>
                 <a:ea typeface="Calibri" pitchFamily="34" charset="-122"/>
@@ -6011,7 +5994,7 @@
         <p:spPr>
           <a:xfrm>
             <a:off x="457200" y="1005840"/>
-            <a:ext cx="2697480" cy="3017520"/>
+            <a:ext cx="2697480" cy="3200400"/>
           </a:xfrm>
           <a:prstGeom prst="rect">
             <a:avLst/>
@@ -6023,7 +6006,7 @@
           <a:effectLst>
             <a:outerShdw sx="100000" sy="100000" kx="0" ky="0" algn="bl" rotWithShape="0" blurRad="101600" dist="38100" dir="8100000">
               <a:srgbClr val="000000">
-                <a:alpha val="30000"/>
+                <a:alpha val="25000"/>
               </a:srgbClr>
             </a:outerShdw>
           </a:effectLst>
@@ -6095,7 +6078,7 @@
             <a:r>
               <a:rPr lang="en-US" sz="1600" b="1" dirty="0">
                 <a:solidFill>
-                  <a:srgbClr val="333333"/>
+                  <a:srgbClr val="222222"/>
                 </a:solidFill>
                 <a:latin typeface="Calibri" pitchFamily="34" charset="0"/>
                 <a:ea typeface="Calibri" pitchFamily="34" charset="-122"/>
@@ -6251,7 +6234,7 @@
         <p:spPr>
           <a:xfrm>
             <a:off x="3337560" y="1005840"/>
-            <a:ext cx="2697480" cy="3017520"/>
+            <a:ext cx="2697480" cy="3200400"/>
           </a:xfrm>
           <a:prstGeom prst="rect">
             <a:avLst/>
@@ -6263,7 +6246,7 @@
           <a:effectLst>
             <a:outerShdw sx="100000" sy="100000" kx="0" ky="0" algn="bl" rotWithShape="0" blurRad="101600" dist="38100" dir="8100000">
               <a:srgbClr val="000000">
-                <a:alpha val="30000"/>
+                <a:alpha val="25000"/>
               </a:srgbClr>
             </a:outerShdw>
           </a:effectLst>
@@ -6335,7 +6318,7 @@
             <a:r>
               <a:rPr lang="en-US" sz="1600" b="1" dirty="0">
                 <a:solidFill>
-                  <a:srgbClr val="333333"/>
+                  <a:srgbClr val="222222"/>
                 </a:solidFill>
                 <a:latin typeface="Calibri" pitchFamily="34" charset="0"/>
                 <a:ea typeface="Calibri" pitchFamily="34" charset="-122"/>
@@ -6491,7 +6474,7 @@
         <p:spPr>
           <a:xfrm>
             <a:off x="6217920" y="1005840"/>
-            <a:ext cx="2697480" cy="3017520"/>
+            <a:ext cx="2697480" cy="3200400"/>
           </a:xfrm>
           <a:prstGeom prst="rect">
             <a:avLst/>
@@ -6503,7 +6486,7 @@
           <a:effectLst>
             <a:outerShdw sx="100000" sy="100000" kx="0" ky="0" algn="bl" rotWithShape="0" blurRad="101600" dist="38100" dir="8100000">
               <a:srgbClr val="000000">
-                <a:alpha val="30000"/>
+                <a:alpha val="25000"/>
               </a:srgbClr>
             </a:outerShdw>
           </a:effectLst>
@@ -6575,7 +6558,7 @@
             <a:r>
               <a:rPr lang="en-US" sz="1600" b="1" dirty="0">
                 <a:solidFill>
-                  <a:srgbClr val="333333"/>
+                  <a:srgbClr val="222222"/>
                 </a:solidFill>
                 <a:latin typeface="Calibri" pitchFamily="34" charset="0"/>
                 <a:ea typeface="Calibri" pitchFamily="34" charset="-122"/>
@@ -6730,7 +6713,7 @@
         </p:nvSpPr>
         <p:spPr>
           <a:xfrm>
-            <a:off x="457200" y="4297680"/>
+            <a:off x="457200" y="4434840"/>
             <a:ext cx="8229600" cy="594360"/>
           </a:xfrm>
           <a:prstGeom prst="rect">
@@ -6743,7 +6726,7 @@
           <a:effectLst>
             <a:outerShdw sx="100000" sy="100000" kx="0" ky="0" algn="bl" rotWithShape="0" blurRad="101600" dist="38100" dir="8100000">
               <a:srgbClr val="000000">
-                <a:alpha val="30000"/>
+                <a:alpha val="25000"/>
               </a:srgbClr>
             </a:outerShdw>
           </a:effectLst>
@@ -6757,7 +6740,7 @@
         </p:nvSpPr>
         <p:spPr>
           <a:xfrm>
-            <a:off x="640080" y="4370832"/>
+            <a:off x="640080" y="4498848"/>
             <a:ext cx="7863840" cy="457200"/>
           </a:xfrm>
           <a:prstGeom prst="rect">
@@ -6796,7 +6779,7 @@
         </p:nvSpPr>
         <p:spPr>
           <a:xfrm>
-            <a:off x="7772400" y="4572000"/>
+            <a:off x="7772400" y="4754880"/>
             <a:ext cx="1097280" cy="320040"/>
           </a:xfrm>
           <a:prstGeom prst="rect">
@@ -6939,7 +6922,7 @@
           <a:effectLst>
             <a:outerShdw sx="100000" sy="100000" kx="0" ky="0" algn="bl" rotWithShape="0" blurRad="101600" dist="38100" dir="8100000">
               <a:srgbClr val="000000">
-                <a:alpha val="30000"/>
+                <a:alpha val="25000"/>
               </a:srgbClr>
             </a:outerShdw>
           </a:effectLst>
@@ -6970,7 +6953,7 @@
               <a:buNone/>
             </a:pPr>
             <a:r>
-              <a:rPr lang="en-US" sz="3600" b="1" dirty="0">
+              <a:rPr lang="en-US" sz="3800" b="1" dirty="0">
                 <a:solidFill>
                   <a:srgbClr val="ED1C24"/>
                 </a:solidFill>
@@ -6980,7 +6963,7 @@
               </a:rPr>
               <a:t>~105s</a:t>
             </a:r>
-            <a:endParaRPr lang="en-US" sz="3600" dirty="0"/>
+            <a:endParaRPr lang="en-US" sz="3800" dirty="0"/>
           </a:p>
         </p:txBody>
       </p:sp>
@@ -7017,7 +7000,7 @@
                 <a:ea typeface="Calibri Light" pitchFamily="34" charset="-122"/>
                 <a:cs typeface="Calibri Light" pitchFamily="34" charset="-120"/>
               </a:rPr>
-              <a:t>Pipeline per kernel</a:t>
+              <a:t>Per kernel pipeline</a:t>
             </a:r>
             <a:endParaRPr lang="en-US" sz="1200" dirty="0"/>
           </a:p>
@@ -7044,7 +7027,7 @@
           <a:effectLst>
             <a:outerShdw sx="100000" sy="100000" kx="0" ky="0" algn="bl" rotWithShape="0" blurRad="101600" dist="38100" dir="8100000">
               <a:srgbClr val="000000">
-                <a:alpha val="30000"/>
+                <a:alpha val="25000"/>
               </a:srgbClr>
             </a:outerShdw>
           </a:effectLst>
@@ -7075,7 +7058,7 @@
               <a:buNone/>
             </a:pPr>
             <a:r>
-              <a:rPr lang="en-US" sz="3600" b="1" dirty="0">
+              <a:rPr lang="en-US" sz="3800" b="1" dirty="0">
                 <a:solidFill>
                   <a:srgbClr val="ED1C24"/>
                 </a:solidFill>
@@ -7085,7 +7068,7 @@
               </a:rPr>
               <a:t>~$0.03</a:t>
             </a:r>
-            <a:endParaRPr lang="en-US" sz="3600" dirty="0"/>
+            <a:endParaRPr lang="en-US" sz="3800" dirty="0"/>
           </a:p>
         </p:txBody>
       </p:sp>
@@ -7122,7 +7105,7 @@
                 <a:ea typeface="Calibri Light" pitchFamily="34" charset="-122"/>
                 <a:cs typeface="Calibri Light" pitchFamily="34" charset="-120"/>
               </a:rPr>
-              <a:t>Average cost</a:t>
+              <a:t>Average LLM cost</a:t>
             </a:r>
             <a:endParaRPr lang="en-US" sz="1200" dirty="0"/>
           </a:p>
@@ -7149,7 +7132,7 @@
           <a:effectLst>
             <a:outerShdw sx="100000" sy="100000" kx="0" ky="0" algn="bl" rotWithShape="0" blurRad="101600" dist="38100" dir="8100000">
               <a:srgbClr val="000000">
-                <a:alpha val="30000"/>
+                <a:alpha val="25000"/>
               </a:srgbClr>
             </a:outerShdw>
           </a:effectLst>
@@ -7180,7 +7163,7 @@
               <a:buNone/>
             </a:pPr>
             <a:r>
-              <a:rPr lang="en-US" sz="3600" b="1" dirty="0">
+              <a:rPr lang="en-US" sz="3800" b="1" dirty="0">
                 <a:solidFill>
                   <a:srgbClr val="ED1C24"/>
                 </a:solidFill>
@@ -7188,9 +7171,9 @@
                 <a:ea typeface="Calibri" pitchFamily="34" charset="-122"/>
                 <a:cs typeface="Calibri" pitchFamily="34" charset="-120"/>
               </a:rPr>
-              <a:t>30+</a:t>
-            </a:r>
-            <a:endParaRPr lang="en-US" sz="3600" dirty="0"/>
+              <a:t>30+/hr</a:t>
+            </a:r>
+            <a:endParaRPr lang="en-US" sz="3800" dirty="0"/>
           </a:p>
         </p:txBody>
       </p:sp>
@@ -7227,7 +7210,7 @@
                 <a:ea typeface="Calibri Light" pitchFamily="34" charset="-122"/>
                 <a:cs typeface="Calibri Light" pitchFamily="34" charset="-120"/>
               </a:rPr>
-              <a:t>Kernels/hr</a:t>
+              <a:t>Throughput</a:t>
             </a:r>
             <a:endParaRPr lang="en-US" sz="1200" dirty="0"/>
           </a:p>
@@ -7242,7 +7225,7 @@
         <p:spPr>
           <a:xfrm>
             <a:off x="457200" y="2468880"/>
-            <a:ext cx="2743200" cy="365760"/>
+            <a:ext cx="8229600" cy="320040"/>
           </a:xfrm>
           <a:prstGeom prst="rect">
             <a:avLst/>
@@ -7280,7 +7263,7 @@
         </p:nvSpPr>
         <p:spPr>
           <a:xfrm>
-            <a:off x="457200" y="2926080"/>
+            <a:off x="457200" y="2880360"/>
             <a:ext cx="8229600" cy="365760"/>
           </a:xfrm>
           <a:prstGeom prst="rect">
@@ -7300,7 +7283,7 @@
         </p:nvSpPr>
         <p:spPr>
           <a:xfrm>
-            <a:off x="640080" y="2926080"/>
+            <a:off x="640080" y="2880360"/>
             <a:ext cx="7863840" cy="365760"/>
           </a:xfrm>
           <a:prstGeom prst="rect">
@@ -7325,49 +7308,144 @@
                 <a:ea typeface="Calibri" pitchFamily="34" charset="-122"/>
                 <a:cs typeface="Calibri" pitchFamily="34" charset="-120"/>
               </a:rPr>
-              <a:t>Approach        </a:t>
-            </a:r>
+              <a:t>  Approach                     Time            Cost             Confidence</a:t>
+            </a:r>
+            <a:endParaRPr lang="en-US" sz="1100" dirty="0"/>
+          </a:p>
+        </p:txBody>
+      </p:sp>
+      <p:sp>
+        <p:nvSpPr>
+          <p:cNvPr id="16" name="Shape 14"/>
+          <p:cNvSpPr/>
+          <p:nvPr/>
+        </p:nvSpPr>
+        <p:spPr>
+          <a:xfrm>
+            <a:off x="457200" y="3291840"/>
+            <a:ext cx="8229600" cy="420624"/>
+          </a:xfrm>
+          <a:prstGeom prst="rect">
+            <a:avLst/>
+          </a:prstGeom>
+          <a:solidFill>
+            <a:srgbClr val="1E1E30"/>
+          </a:solidFill>
+          <a:ln/>
+        </p:spPr>
+      </p:sp>
+      <p:sp>
+        <p:nvSpPr>
+          <p:cNvPr id="17" name="Text 15"/>
+          <p:cNvSpPr/>
+          <p:nvPr/>
+        </p:nvSpPr>
+        <p:spPr>
+          <a:xfrm>
+            <a:off x="640080" y="3291840"/>
+            <a:ext cx="2926080" cy="420624"/>
+          </a:xfrm>
+          <a:prstGeom prst="rect">
+            <a:avLst/>
+          </a:prstGeom>
+          <a:noFill/>
+          <a:ln/>
+        </p:spPr>
+        <p:txBody>
+          <a:bodyPr wrap="square" lIns="0" tIns="0" rIns="0" bIns="0" rtlCol="0" anchor="ctr"/>
+          <a:lstStyle/>
+          <a:p>
             <a:pPr indent="0" marL="0">
               <a:buNone/>
             </a:pPr>
             <a:r>
-              <a:rPr lang="en-US" sz="1100" b="1" dirty="0">
-                <a:solidFill>
-                  <a:srgbClr val="FFFFFF"/>
+              <a:rPr lang="en-US" sz="1100" dirty="0">
+                <a:solidFill>
+                  <a:srgbClr val="DDDDDD"/>
                 </a:solidFill>
                 <a:latin typeface="Calibri" pitchFamily="34" charset="0"/>
                 <a:ea typeface="Calibri" pitchFamily="34" charset="-122"/>
                 <a:cs typeface="Calibri" pitchFamily="34" charset="-120"/>
               </a:rPr>
-              <a:t>Time        </a:t>
-            </a:r>
+              <a:t>Manual (expert engineer)</a:t>
+            </a:r>
+            <a:endParaRPr lang="en-US" sz="1100" dirty="0"/>
+          </a:p>
+        </p:txBody>
+      </p:sp>
+      <p:sp>
+        <p:nvSpPr>
+          <p:cNvPr id="18" name="Text 16"/>
+          <p:cNvSpPr/>
+          <p:nvPr/>
+        </p:nvSpPr>
+        <p:spPr>
+          <a:xfrm>
+            <a:off x="3566160" y="3291840"/>
+            <a:ext cx="1371600" cy="420624"/>
+          </a:xfrm>
+          <a:prstGeom prst="rect">
+            <a:avLst/>
+          </a:prstGeom>
+          <a:noFill/>
+          <a:ln/>
+        </p:spPr>
+        <p:txBody>
+          <a:bodyPr wrap="square" lIns="0" tIns="0" rIns="0" bIns="0" rtlCol="0" anchor="ctr"/>
+          <a:lstStyle/>
+          <a:p>
             <a:pPr indent="0" marL="0">
               <a:buNone/>
             </a:pPr>
             <a:r>
-              <a:rPr lang="en-US" sz="1100" b="1" dirty="0">
-                <a:solidFill>
-                  <a:srgbClr val="FFFFFF"/>
+              <a:rPr lang="en-US" sz="1100" dirty="0">
+                <a:solidFill>
+                  <a:srgbClr val="AAAAAA"/>
                 </a:solidFill>
                 <a:latin typeface="Calibri" pitchFamily="34" charset="0"/>
                 <a:ea typeface="Calibri" pitchFamily="34" charset="-122"/>
                 <a:cs typeface="Calibri" pitchFamily="34" charset="-120"/>
               </a:rPr>
-              <a:t>Cost          </a:t>
-            </a:r>
+              <a:t>2–4 weeks</a:t>
+            </a:r>
+            <a:endParaRPr lang="en-US" sz="1100" dirty="0"/>
+          </a:p>
+        </p:txBody>
+      </p:sp>
+      <p:sp>
+        <p:nvSpPr>
+          <p:cNvPr id="19" name="Text 17"/>
+          <p:cNvSpPr/>
+          <p:nvPr/>
+        </p:nvSpPr>
+        <p:spPr>
+          <a:xfrm>
+            <a:off x="4937760" y="3291840"/>
+            <a:ext cx="1371600" cy="420624"/>
+          </a:xfrm>
+          <a:prstGeom prst="rect">
+            <a:avLst/>
+          </a:prstGeom>
+          <a:noFill/>
+          <a:ln/>
+        </p:spPr>
+        <p:txBody>
+          <a:bodyPr wrap="square" lIns="0" tIns="0" rIns="0" bIns="0" rtlCol="0" anchor="ctr"/>
+          <a:lstStyle/>
+          <a:p>
             <a:pPr indent="0" marL="0">
               <a:buNone/>
             </a:pPr>
             <a:r>
-              <a:rPr lang="en-US" sz="1100" b="1" dirty="0">
-                <a:solidFill>
-                  <a:srgbClr val="FFFFFF"/>
+              <a:rPr lang="en-US" sz="1100" dirty="0">
+                <a:solidFill>
+                  <a:srgbClr val="AAAAAA"/>
                 </a:solidFill>
                 <a:latin typeface="Calibri" pitchFamily="34" charset="0"/>
                 <a:ea typeface="Calibri" pitchFamily="34" charset="-122"/>
                 <a:cs typeface="Calibri" pitchFamily="34" charset="-120"/>
               </a:rPr>
-              <a:t>Confidence</a:t>
+              <a:t>$8,000</a:t>
             </a:r>
             <a:endParaRPr lang="en-US" sz="1100" dirty="0"/>
           </a:p>
@@ -7375,14 +7453,53 @@
       </p:sp>
       <p:sp>
         <p:nvSpPr>
-          <p:cNvPr id="16" name="Shape 14"/>
-          <p:cNvSpPr/>
-          <p:nvPr/>
-        </p:nvSpPr>
-        <p:spPr>
-          <a:xfrm>
-            <a:off x="457200" y="3337560"/>
-            <a:ext cx="8229600" cy="384048"/>
+          <p:cNvPr id="20" name="Text 18"/>
+          <p:cNvSpPr/>
+          <p:nvPr/>
+        </p:nvSpPr>
+        <p:spPr>
+          <a:xfrm>
+            <a:off x="6583680" y="3291840"/>
+            <a:ext cx="914400" cy="420624"/>
+          </a:xfrm>
+          <a:prstGeom prst="rect">
+            <a:avLst/>
+          </a:prstGeom>
+          <a:noFill/>
+          <a:ln/>
+        </p:spPr>
+        <p:txBody>
+          <a:bodyPr wrap="square" lIns="0" tIns="0" rIns="0" bIns="0" rtlCol="0" anchor="ctr"/>
+          <a:lstStyle/>
+          <a:p>
+            <a:pPr indent="0" marL="0">
+              <a:buNone/>
+            </a:pPr>
+            <a:r>
+              <a:rPr lang="en-US" sz="1100" dirty="0">
+                <a:solidFill>
+                  <a:srgbClr val="AAAAAA"/>
+                </a:solidFill>
+                <a:latin typeface="Calibri" pitchFamily="34" charset="0"/>
+                <a:ea typeface="Calibri" pitchFamily="34" charset="-122"/>
+                <a:cs typeface="Calibri" pitchFamily="34" charset="-120"/>
+              </a:rPr>
+              <a:t>Variable</a:t>
+            </a:r>
+            <a:endParaRPr lang="en-US" sz="1100" dirty="0"/>
+          </a:p>
+        </p:txBody>
+      </p:sp>
+      <p:sp>
+        <p:nvSpPr>
+          <p:cNvPr id="21" name="Shape 19"/>
+          <p:cNvSpPr/>
+          <p:nvPr/>
+        </p:nvSpPr>
+        <p:spPr>
+          <a:xfrm>
+            <a:off x="457200" y="3749040"/>
+            <a:ext cx="8229600" cy="420624"/>
           </a:xfrm>
           <a:prstGeom prst="rect">
             <a:avLst/>
@@ -7395,14 +7512,14 @@
       </p:sp>
       <p:sp>
         <p:nvSpPr>
-          <p:cNvPr id="17" name="Text 15"/>
-          <p:cNvSpPr/>
-          <p:nvPr/>
-        </p:nvSpPr>
-        <p:spPr>
-          <a:xfrm>
-            <a:off x="640080" y="3337560"/>
-            <a:ext cx="7863840" cy="384048"/>
+          <p:cNvPr id="22" name="Text 20"/>
+          <p:cNvSpPr/>
+          <p:nvPr/>
+        </p:nvSpPr>
+        <p:spPr>
+          <a:xfrm>
+            <a:off x="640080" y="3749040"/>
+            <a:ext cx="2926080" cy="420624"/>
           </a:xfrm>
           <a:prstGeom prst="rect">
             <a:avLst/>
@@ -7422,12 +7539,37 @@
                 <a:solidFill>
                   <a:srgbClr val="DDDDDD"/>
                 </a:solidFill>
-                <a:latin typeface="Consolas" pitchFamily="34" charset="0"/>
-                <a:ea typeface="Consolas" pitchFamily="34" charset="-122"/>
-                <a:cs typeface="Consolas" pitchFamily="34" charset="-120"/>
-              </a:rPr>
-              <a:t>Manual (expert engineer)</a:t>
-            </a:r>
+                <a:latin typeface="Calibri" pitchFamily="34" charset="0"/>
+                <a:ea typeface="Calibri" pitchFamily="34" charset="-122"/>
+                <a:cs typeface="Calibri" pitchFamily="34" charset="-120"/>
+              </a:rPr>
+              <a:t>hipify + manual fix</a:t>
+            </a:r>
+            <a:endParaRPr lang="en-US" sz="1100" dirty="0"/>
+          </a:p>
+        </p:txBody>
+      </p:sp>
+      <p:sp>
+        <p:nvSpPr>
+          <p:cNvPr id="23" name="Text 21"/>
+          <p:cNvSpPr/>
+          <p:nvPr/>
+        </p:nvSpPr>
+        <p:spPr>
+          <a:xfrm>
+            <a:off x="3566160" y="3749040"/>
+            <a:ext cx="1371600" cy="420624"/>
+          </a:xfrm>
+          <a:prstGeom prst="rect">
+            <a:avLst/>
+          </a:prstGeom>
+          <a:noFill/>
+          <a:ln/>
+        </p:spPr>
+        <p:txBody>
+          <a:bodyPr wrap="square" lIns="0" tIns="0" rIns="0" bIns="0" rtlCol="0" anchor="ctr"/>
+          <a:lstStyle/>
+          <a:p>
             <a:pPr indent="0" marL="0">
               <a:buNone/>
             </a:pPr>
@@ -7436,12 +7578,37 @@
                 <a:solidFill>
                   <a:srgbClr val="AAAAAA"/>
                 </a:solidFill>
-                <a:latin typeface="Consolas" pitchFamily="34" charset="0"/>
-                <a:ea typeface="Consolas" pitchFamily="34" charset="-122"/>
-                <a:cs typeface="Consolas" pitchFamily="34" charset="-120"/>
-              </a:rPr>
-              <a:t>2–4 weeks     </a:t>
-            </a:r>
+                <a:latin typeface="Calibri" pitchFamily="34" charset="0"/>
+                <a:ea typeface="Calibri" pitchFamily="34" charset="-122"/>
+                <a:cs typeface="Calibri" pitchFamily="34" charset="-120"/>
+              </a:rPr>
+              <a:t>3–5 days</a:t>
+            </a:r>
+            <a:endParaRPr lang="en-US" sz="1100" dirty="0"/>
+          </a:p>
+        </p:txBody>
+      </p:sp>
+      <p:sp>
+        <p:nvSpPr>
+          <p:cNvPr id="24" name="Text 22"/>
+          <p:cNvSpPr/>
+          <p:nvPr/>
+        </p:nvSpPr>
+        <p:spPr>
+          <a:xfrm>
+            <a:off x="4937760" y="3749040"/>
+            <a:ext cx="1371600" cy="420624"/>
+          </a:xfrm>
+          <a:prstGeom prst="rect">
+            <a:avLst/>
+          </a:prstGeom>
+          <a:noFill/>
+          <a:ln/>
+        </p:spPr>
+        <p:txBody>
+          <a:bodyPr wrap="square" lIns="0" tIns="0" rIns="0" bIns="0" rtlCol="0" anchor="ctr"/>
+          <a:lstStyle/>
+          <a:p>
             <a:pPr indent="0" marL="0">
               <a:buNone/>
             </a:pPr>
@@ -7450,12 +7617,37 @@
                 <a:solidFill>
                   <a:srgbClr val="AAAAAA"/>
                 </a:solidFill>
-                <a:latin typeface="Consolas" pitchFamily="34" charset="0"/>
-                <a:ea typeface="Consolas" pitchFamily="34" charset="-122"/>
-                <a:cs typeface="Consolas" pitchFamily="34" charset="-120"/>
-              </a:rPr>
-              <a:t>~$8,000         </a:t>
-            </a:r>
+                <a:latin typeface="Calibri" pitchFamily="34" charset="0"/>
+                <a:ea typeface="Calibri" pitchFamily="34" charset="-122"/>
+                <a:cs typeface="Calibri" pitchFamily="34" charset="-120"/>
+              </a:rPr>
+              <a:t>$2,500</a:t>
+            </a:r>
+            <a:endParaRPr lang="en-US" sz="1100" dirty="0"/>
+          </a:p>
+        </p:txBody>
+      </p:sp>
+      <p:sp>
+        <p:nvSpPr>
+          <p:cNvPr id="25" name="Text 23"/>
+          <p:cNvSpPr/>
+          <p:nvPr/>
+        </p:nvSpPr>
+        <p:spPr>
+          <a:xfrm>
+            <a:off x="6583680" y="3749040"/>
+            <a:ext cx="914400" cy="420624"/>
+          </a:xfrm>
+          <a:prstGeom prst="rect">
+            <a:avLst/>
+          </a:prstGeom>
+          <a:noFill/>
+          <a:ln/>
+        </p:spPr>
+        <p:txBody>
+          <a:bodyPr wrap="square" lIns="0" tIns="0" rIns="0" bIns="0" rtlCol="0" anchor="ctr"/>
+          <a:lstStyle/>
+          <a:p>
             <a:pPr indent="0" marL="0">
               <a:buNone/>
             </a:pPr>
@@ -7464,11 +7656,11 @@
                 <a:solidFill>
                   <a:srgbClr val="AAAAAA"/>
                 </a:solidFill>
-                <a:latin typeface="Consolas" pitchFamily="34" charset="0"/>
-                <a:ea typeface="Consolas" pitchFamily="34" charset="-122"/>
-                <a:cs typeface="Consolas" pitchFamily="34" charset="-120"/>
-              </a:rPr>
-              <a:t>Variable</a:t>
+                <a:latin typeface="Calibri" pitchFamily="34" charset="0"/>
+                <a:ea typeface="Calibri" pitchFamily="34" charset="-122"/>
+                <a:cs typeface="Calibri" pitchFamily="34" charset="-120"/>
+              </a:rPr>
+              <a:t>Medium</a:t>
             </a:r>
             <a:endParaRPr lang="en-US" sz="1100" dirty="0"/>
           </a:p>
@@ -7476,115 +7668,14 @@
       </p:sp>
       <p:sp>
         <p:nvSpPr>
-          <p:cNvPr id="18" name="Shape 16"/>
-          <p:cNvSpPr/>
-          <p:nvPr/>
-        </p:nvSpPr>
-        <p:spPr>
-          <a:xfrm>
-            <a:off x="457200" y="3749040"/>
-            <a:ext cx="8229600" cy="384048"/>
-          </a:xfrm>
-          <a:prstGeom prst="rect">
-            <a:avLst/>
-          </a:prstGeom>
-          <a:solidFill>
-            <a:srgbClr val="1E1E30"/>
-          </a:solidFill>
-          <a:ln/>
-        </p:spPr>
-      </p:sp>
-      <p:sp>
-        <p:nvSpPr>
-          <p:cNvPr id="19" name="Text 17"/>
-          <p:cNvSpPr/>
-          <p:nvPr/>
-        </p:nvSpPr>
-        <p:spPr>
-          <a:xfrm>
-            <a:off x="640080" y="3749040"/>
-            <a:ext cx="7863840" cy="384048"/>
-          </a:xfrm>
-          <a:prstGeom prst="rect">
-            <a:avLst/>
-          </a:prstGeom>
-          <a:noFill/>
-          <a:ln/>
-        </p:spPr>
-        <p:txBody>
-          <a:bodyPr wrap="square" lIns="0" tIns="0" rIns="0" bIns="0" rtlCol="0" anchor="ctr"/>
-          <a:lstStyle/>
-          <a:p>
-            <a:pPr indent="0" marL="0">
-              <a:buNone/>
-            </a:pPr>
-            <a:r>
-              <a:rPr lang="en-US" sz="1100" dirty="0">
-                <a:solidFill>
-                  <a:srgbClr val="DDDDDD"/>
-                </a:solidFill>
-                <a:latin typeface="Consolas" pitchFamily="34" charset="0"/>
-                <a:ea typeface="Consolas" pitchFamily="34" charset="-122"/>
-                <a:cs typeface="Consolas" pitchFamily="34" charset="-120"/>
-              </a:rPr>
-              <a:t>hipify + manual fix</a:t>
-            </a:r>
-            <a:pPr indent="0" marL="0">
-              <a:buNone/>
-            </a:pPr>
-            <a:r>
-              <a:rPr lang="en-US" sz="1100" dirty="0">
-                <a:solidFill>
-                  <a:srgbClr val="AAAAAA"/>
-                </a:solidFill>
-                <a:latin typeface="Consolas" pitchFamily="34" charset="0"/>
-                <a:ea typeface="Consolas" pitchFamily="34" charset="-122"/>
-                <a:cs typeface="Consolas" pitchFamily="34" charset="-120"/>
-              </a:rPr>
-              <a:t>3–5 days      </a:t>
-            </a:r>
-            <a:pPr indent="0" marL="0">
-              <a:buNone/>
-            </a:pPr>
-            <a:r>
-              <a:rPr lang="en-US" sz="1100" dirty="0">
-                <a:solidFill>
-                  <a:srgbClr val="AAAAAA"/>
-                </a:solidFill>
-                <a:latin typeface="Consolas" pitchFamily="34" charset="0"/>
-                <a:ea typeface="Consolas" pitchFamily="34" charset="-122"/>
-                <a:cs typeface="Consolas" pitchFamily="34" charset="-120"/>
-              </a:rPr>
-              <a:t>~$2,500         </a:t>
-            </a:r>
-            <a:pPr indent="0" marL="0">
-              <a:buNone/>
-            </a:pPr>
-            <a:r>
-              <a:rPr lang="en-US" sz="1100" dirty="0">
-                <a:solidFill>
-                  <a:srgbClr val="AAAAAA"/>
-                </a:solidFill>
-                <a:latin typeface="Consolas" pitchFamily="34" charset="0"/>
-                <a:ea typeface="Consolas" pitchFamily="34" charset="-122"/>
-                <a:cs typeface="Consolas" pitchFamily="34" charset="-120"/>
-              </a:rPr>
-              <a:t>Medium</a:t>
-            </a:r>
-            <a:endParaRPr lang="en-US" sz="1100" dirty="0"/>
-          </a:p>
-        </p:txBody>
-      </p:sp>
-      <p:sp>
-        <p:nvSpPr>
-          <p:cNvPr id="20" name="Shape 18"/>
-          <p:cNvSpPr/>
-          <p:nvPr/>
-        </p:nvSpPr>
-        <p:spPr>
-          <a:xfrm>
-            <a:off x="457200" y="4160520"/>
-            <a:ext cx="8229600" cy="384048"/>
+          <p:cNvPr id="26" name="Shape 24"/>
+          <p:cNvSpPr/>
+          <p:nvPr/>
+        </p:nvSpPr>
+        <p:spPr>
+          <a:xfrm>
+            <a:off x="457200" y="4206240"/>
+            <a:ext cx="8229600" cy="420624"/>
           </a:xfrm>
           <a:prstGeom prst="rect">
             <a:avLst/>
@@ -7597,14 +7688,14 @@
       </p:sp>
       <p:sp>
         <p:nvSpPr>
-          <p:cNvPr id="21" name="Text 19"/>
-          <p:cNvSpPr/>
-          <p:nvPr/>
-        </p:nvSpPr>
-        <p:spPr>
-          <a:xfrm>
-            <a:off x="640080" y="4160520"/>
-            <a:ext cx="7863840" cy="384048"/>
+          <p:cNvPr id="27" name="Text 25"/>
+          <p:cNvSpPr/>
+          <p:nvPr/>
+        </p:nvSpPr>
+        <p:spPr>
+          <a:xfrm>
+            <a:off x="640080" y="4206240"/>
+            <a:ext cx="2926080" cy="420624"/>
           </a:xfrm>
           <a:prstGeom prst="rect">
             <a:avLst/>
@@ -7620,16 +7711,41 @@
               <a:buNone/>
             </a:pPr>
             <a:r>
-              <a:rPr lang="en-US" sz="1100" dirty="0">
+              <a:rPr lang="en-US" sz="1100" b="1" dirty="0">
                 <a:solidFill>
                   <a:srgbClr val="DDDDDD"/>
                 </a:solidFill>
-                <a:latin typeface="Consolas" pitchFamily="34" charset="0"/>
-                <a:ea typeface="Consolas" pitchFamily="34" charset="-122"/>
-                <a:cs typeface="Consolas" pitchFamily="34" charset="-120"/>
-              </a:rPr>
-              <a:t>Kernel Olympics   </a:t>
-            </a:r>
+                <a:latin typeface="Calibri" pitchFamily="34" charset="0"/>
+                <a:ea typeface="Calibri" pitchFamily="34" charset="-122"/>
+                <a:cs typeface="Calibri" pitchFamily="34" charset="-120"/>
+              </a:rPr>
+              <a:t>Kernel Olympics</a:t>
+            </a:r>
+            <a:endParaRPr lang="en-US" sz="1100" dirty="0"/>
+          </a:p>
+        </p:txBody>
+      </p:sp>
+      <p:sp>
+        <p:nvSpPr>
+          <p:cNvPr id="28" name="Text 26"/>
+          <p:cNvSpPr/>
+          <p:nvPr/>
+        </p:nvSpPr>
+        <p:spPr>
+          <a:xfrm>
+            <a:off x="3566160" y="4206240"/>
+            <a:ext cx="1371600" cy="420624"/>
+          </a:xfrm>
+          <a:prstGeom prst="rect">
+            <a:avLst/>
+          </a:prstGeom>
+          <a:noFill/>
+          <a:ln/>
+        </p:spPr>
+        <p:txBody>
+          <a:bodyPr wrap="square" lIns="0" tIns="0" rIns="0" bIns="0" rtlCol="0" anchor="ctr"/>
+          <a:lstStyle/>
+          <a:p>
             <a:pPr indent="0" marL="0">
               <a:buNone/>
             </a:pPr>
@@ -7638,12 +7754,37 @@
                 <a:solidFill>
                   <a:srgbClr val="4ECB71"/>
                 </a:solidFill>
-                <a:latin typeface="Consolas" pitchFamily="34" charset="0"/>
-                <a:ea typeface="Consolas" pitchFamily="34" charset="-122"/>
-                <a:cs typeface="Consolas" pitchFamily="34" charset="-120"/>
-              </a:rPr>
-              <a:t>105 seconds   </a:t>
-            </a:r>
+                <a:latin typeface="Calibri" pitchFamily="34" charset="0"/>
+                <a:ea typeface="Calibri" pitchFamily="34" charset="-122"/>
+                <a:cs typeface="Calibri" pitchFamily="34" charset="-120"/>
+              </a:rPr>
+              <a:t>105s</a:t>
+            </a:r>
+            <a:endParaRPr lang="en-US" sz="1100" dirty="0"/>
+          </a:p>
+        </p:txBody>
+      </p:sp>
+      <p:sp>
+        <p:nvSpPr>
+          <p:cNvPr id="29" name="Text 27"/>
+          <p:cNvSpPr/>
+          <p:nvPr/>
+        </p:nvSpPr>
+        <p:spPr>
+          <a:xfrm>
+            <a:off x="4937760" y="4206240"/>
+            <a:ext cx="1371600" cy="420624"/>
+          </a:xfrm>
+          <a:prstGeom prst="rect">
+            <a:avLst/>
+          </a:prstGeom>
+          <a:noFill/>
+          <a:ln/>
+        </p:spPr>
+        <p:txBody>
+          <a:bodyPr wrap="square" lIns="0" tIns="0" rIns="0" bIns="0" rtlCol="0" anchor="ctr"/>
+          <a:lstStyle/>
+          <a:p>
             <a:pPr indent="0" marL="0">
               <a:buNone/>
             </a:pPr>
@@ -7652,12 +7793,37 @@
                 <a:solidFill>
                   <a:srgbClr val="4ECB71"/>
                 </a:solidFill>
-                <a:latin typeface="Consolas" pitchFamily="34" charset="0"/>
-                <a:ea typeface="Consolas" pitchFamily="34" charset="-122"/>
-                <a:cs typeface="Consolas" pitchFamily="34" charset="-120"/>
-              </a:rPr>
-              <a:t>~$0.03          </a:t>
-            </a:r>
+                <a:latin typeface="Calibri" pitchFamily="34" charset="0"/>
+                <a:ea typeface="Calibri" pitchFamily="34" charset="-122"/>
+                <a:cs typeface="Calibri" pitchFamily="34" charset="-120"/>
+              </a:rPr>
+              <a:t>$0.03</a:t>
+            </a:r>
+            <a:endParaRPr lang="en-US" sz="1100" dirty="0"/>
+          </a:p>
+        </p:txBody>
+      </p:sp>
+      <p:sp>
+        <p:nvSpPr>
+          <p:cNvPr id="30" name="Text 28"/>
+          <p:cNvSpPr/>
+          <p:nvPr/>
+        </p:nvSpPr>
+        <p:spPr>
+          <a:xfrm>
+            <a:off x="6583680" y="4206240"/>
+            <a:ext cx="914400" cy="420624"/>
+          </a:xfrm>
+          <a:prstGeom prst="rect">
+            <a:avLst/>
+          </a:prstGeom>
+          <a:noFill/>
+          <a:ln/>
+        </p:spPr>
+        <p:txBody>
+          <a:bodyPr wrap="square" lIns="0" tIns="0" rIns="0" bIns="0" rtlCol="0" anchor="ctr"/>
+          <a:lstStyle/>
+          <a:p>
             <a:pPr indent="0" marL="0">
               <a:buNone/>
             </a:pPr>
@@ -7666,9 +7832,9 @@
                 <a:solidFill>
                   <a:srgbClr val="4ECB71"/>
                 </a:solidFill>
-                <a:latin typeface="Consolas" pitchFamily="34" charset="0"/>
-                <a:ea typeface="Consolas" pitchFamily="34" charset="-122"/>
-                <a:cs typeface="Consolas" pitchFamily="34" charset="-120"/>
+                <a:latin typeface="Calibri" pitchFamily="34" charset="0"/>
+                <a:ea typeface="Calibri" pitchFamily="34" charset="-122"/>
+                <a:cs typeface="Calibri" pitchFamily="34" charset="-120"/>
               </a:rPr>
               <a:t>96%</a:t>
             </a:r>
@@ -7678,13 +7844,13 @@
       </p:sp>
       <p:sp>
         <p:nvSpPr>
-          <p:cNvPr id="22" name="Shape 20"/>
-          <p:cNvSpPr/>
-          <p:nvPr/>
-        </p:nvSpPr>
-        <p:spPr>
-          <a:xfrm>
-            <a:off x="457200" y="4572000"/>
+          <p:cNvPr id="31" name="Shape 29"/>
+          <p:cNvSpPr/>
+          <p:nvPr/>
+        </p:nvSpPr>
+        <p:spPr>
+          <a:xfrm>
+            <a:off x="457200" y="4663440"/>
             <a:ext cx="8229600" cy="411480"/>
           </a:xfrm>
           <a:prstGeom prst="rect">
@@ -7698,13 +7864,13 @@
       </p:sp>
       <p:sp>
         <p:nvSpPr>
-          <p:cNvPr id="23" name="Text 21"/>
-          <p:cNvSpPr/>
-          <p:nvPr/>
-        </p:nvSpPr>
-        <p:spPr>
-          <a:xfrm>
-            <a:off x="640080" y="4590288"/>
+          <p:cNvPr id="32" name="Text 30"/>
+          <p:cNvSpPr/>
+          <p:nvPr/>
+        </p:nvSpPr>
+        <p:spPr>
+          <a:xfrm>
+            <a:off x="640080" y="4681728"/>
             <a:ext cx="7863840" cy="365760"/>
           </a:xfrm>
           <a:prstGeom prst="rect">
@@ -7729,7 +7895,7 @@
                 <a:ea typeface="Calibri" pitchFamily="34" charset="-122"/>
                 <a:cs typeface="Calibri" pitchFamily="34" charset="-120"/>
               </a:rPr>
-              <a:t>⚡ Pattern memory: 0.2ms lookup vs ~12s LLM call = 60,000× speedup for cached patterns</a:t>
+              <a:t>Pattern memory: 0.2ms lookup vs ~12s LLM call = 60,000× speedup for cached patterns</a:t>
             </a:r>
             <a:endParaRPr lang="en-US" sz="1200" dirty="0"/>
           </a:p>
@@ -7737,13 +7903,13 @@
       </p:sp>
       <p:sp>
         <p:nvSpPr>
-          <p:cNvPr id="24" name="Text 22"/>
-          <p:cNvSpPr/>
-          <p:nvPr/>
-        </p:nvSpPr>
-        <p:spPr>
-          <a:xfrm>
-            <a:off x="7772400" y="4572000"/>
+          <p:cNvPr id="33" name="Text 31"/>
+          <p:cNvSpPr/>
+          <p:nvPr/>
+        </p:nvSpPr>
+        <p:spPr>
+          <a:xfrm>
+            <a:off x="7772400" y="4754880"/>
             <a:ext cx="1097280" cy="320040"/>
           </a:xfrm>
           <a:prstGeom prst="rect">
@@ -7853,7 +8019,7 @@
             <a:r>
               <a:rPr lang="en-US" sz="2200" b="1" dirty="0">
                 <a:solidFill>
-                  <a:srgbClr val="FFFFFF"/>
+                  <a:srgbClr val="222222"/>
                 </a:solidFill>
                 <a:latin typeface="Calibri" pitchFamily="34" charset="0"/>
                 <a:ea typeface="Calibri" pitchFamily="34" charset="-122"/>
@@ -7886,7 +8052,7 @@
           <a:effectLst>
             <a:outerShdw sx="100000" sy="100000" kx="0" ky="0" algn="bl" rotWithShape="0" blurRad="101600" dist="38100" dir="8100000">
               <a:srgbClr val="000000">
-                <a:alpha val="30000"/>
+                <a:alpha val="25000"/>
               </a:srgbClr>
             </a:outerShdw>
           </a:effectLst>
@@ -7939,7 +8105,7 @@
             <a:r>
               <a:rPr lang="en-US" sz="1400" b="1" dirty="0">
                 <a:solidFill>
-                  <a:srgbClr val="333333"/>
+                  <a:srgbClr val="222222"/>
                 </a:solidFill>
                 <a:latin typeface="Calibri" pitchFamily="34" charset="0"/>
                 <a:ea typeface="Calibri" pitchFamily="34" charset="-122"/>
@@ -8017,13 +8183,13 @@
             <a:r>
               <a:rPr lang="en-US" sz="1000" dirty="0">
                 <a:solidFill>
-                  <a:srgbClr val="666666"/>
+                  <a:srgbClr val="555555"/>
                 </a:solidFill>
                 <a:latin typeface="Calibri Light" pitchFamily="34" charset="0"/>
                 <a:ea typeface="Calibri Light" pitchFamily="34" charset="-122"/>
                 <a:cs typeface="Calibri Light" pitchFamily="34" charset="-120"/>
               </a:rPr>
-              <a:t>Pipeline architecture, LLM orchestration, 3-gate validation, Railway deployment</a:t>
+              <a:t>Pipeline architecture, LLM orchestration, 3-gate validation, Railway deploy</a:t>
             </a:r>
             <a:endParaRPr lang="en-US" sz="1000" dirty="0"/>
           </a:p>
@@ -8050,7 +8216,7 @@
           <a:effectLst>
             <a:outerShdw sx="100000" sy="100000" kx="0" ky="0" algn="bl" rotWithShape="0" blurRad="101600" dist="38100" dir="8100000">
               <a:srgbClr val="000000">
-                <a:alpha val="30000"/>
+                <a:alpha val="25000"/>
               </a:srgbClr>
             </a:outerShdw>
           </a:effectLst>
@@ -8103,7 +8269,7 @@
             <a:r>
               <a:rPr lang="en-US" sz="1400" b="1" dirty="0">
                 <a:solidFill>
-                  <a:srgbClr val="333333"/>
+                  <a:srgbClr val="222222"/>
                 </a:solidFill>
                 <a:latin typeface="Calibri" pitchFamily="34" charset="0"/>
                 <a:ea typeface="Calibri" pitchFamily="34" charset="-122"/>
@@ -8181,7 +8347,7 @@
             <a:r>
               <a:rPr lang="en-US" sz="1000" dirty="0">
                 <a:solidFill>
-                  <a:srgbClr val="666666"/>
+                  <a:srgbClr val="555555"/>
                 </a:solidFill>
                 <a:latin typeface="Calibri Light" pitchFamily="34" charset="0"/>
                 <a:ea typeface="Calibri Light" pitchFamily="34" charset="-122"/>
@@ -8214,7 +8380,7 @@
           <a:effectLst>
             <a:outerShdw sx="100000" sy="100000" kx="0" ky="0" algn="bl" rotWithShape="0" blurRad="101600" dist="38100" dir="8100000">
               <a:srgbClr val="000000">
-                <a:alpha val="30000"/>
+                <a:alpha val="25000"/>
               </a:srgbClr>
             </a:outerShdw>
           </a:effectLst>
@@ -8267,7 +8433,7 @@
             <a:r>
               <a:rPr lang="en-US" sz="1400" b="1" dirty="0">
                 <a:solidFill>
-                  <a:srgbClr val="333333"/>
+                  <a:srgbClr val="222222"/>
                 </a:solidFill>
                 <a:latin typeface="Calibri" pitchFamily="34" charset="0"/>
                 <a:ea typeface="Calibri" pitchFamily="34" charset="-122"/>
@@ -8345,7 +8511,7 @@
             <a:r>
               <a:rPr lang="en-US" sz="1000" dirty="0">
                 <a:solidFill>
-                  <a:srgbClr val="666666"/>
+                  <a:srgbClr val="555555"/>
                 </a:solidFill>
                 <a:latin typeface="Calibri Light" pitchFamily="34" charset="0"/>
                 <a:ea typeface="Calibri Light" pitchFamily="34" charset="-122"/>
@@ -8378,7 +8544,7 @@
           <a:effectLst>
             <a:outerShdw sx="100000" sy="100000" kx="0" ky="0" algn="bl" rotWithShape="0" blurRad="101600" dist="38100" dir="8100000">
               <a:srgbClr val="000000">
-                <a:alpha val="30000"/>
+                <a:alpha val="25000"/>
               </a:srgbClr>
             </a:outerShdw>
           </a:effectLst>
@@ -8431,7 +8597,7 @@
             <a:r>
               <a:rPr lang="en-US" sz="1400" b="1" dirty="0">
                 <a:solidFill>
-                  <a:srgbClr val="333333"/>
+                  <a:srgbClr val="222222"/>
                 </a:solidFill>
                 <a:latin typeface="Calibri" pitchFamily="34" charset="0"/>
                 <a:ea typeface="Calibri" pitchFamily="34" charset="-122"/>
@@ -8509,7 +8675,7 @@
             <a:r>
               <a:rPr lang="en-US" sz="1000" dirty="0">
                 <a:solidFill>
-                  <a:srgbClr val="666666"/>
+                  <a:srgbClr val="555555"/>
                 </a:solidFill>
                 <a:latin typeface="Calibri Light" pitchFamily="34" charset="0"/>
                 <a:ea typeface="Calibri Light" pitchFamily="34" charset="-122"/>
@@ -8542,7 +8708,7 @@
           <a:effectLst>
             <a:outerShdw sx="100000" sy="100000" kx="0" ky="0" algn="bl" rotWithShape="0" blurRad="101600" dist="38100" dir="8100000">
               <a:srgbClr val="000000">
-                <a:alpha val="30000"/>
+                <a:alpha val="25000"/>
               </a:srgbClr>
             </a:outerShdw>
           </a:effectLst>
@@ -8595,7 +8761,7 @@
             <a:r>
               <a:rPr lang="en-US" sz="1400" b="1" dirty="0">
                 <a:solidFill>
-                  <a:srgbClr val="333333"/>
+                  <a:srgbClr val="222222"/>
                 </a:solidFill>
                 <a:latin typeface="Calibri" pitchFamily="34" charset="0"/>
                 <a:ea typeface="Calibri" pitchFamily="34" charset="-122"/>
@@ -8673,7 +8839,7 @@
             <a:r>
               <a:rPr lang="en-US" sz="1000" dirty="0">
                 <a:solidFill>
-                  <a:srgbClr val="666666"/>
+                  <a:srgbClr val="555555"/>
                 </a:solidFill>
                 <a:latin typeface="Calibri Light" pitchFamily="34" charset="0"/>
                 <a:ea typeface="Calibri Light" pitchFamily="34" charset="-122"/>
@@ -8706,7 +8872,7 @@
           <a:effectLst>
             <a:outerShdw sx="100000" sy="100000" kx="0" ky="0" algn="bl" rotWithShape="0" blurRad="101600" dist="38100" dir="8100000">
               <a:srgbClr val="000000">
-                <a:alpha val="30000"/>
+                <a:alpha val="25000"/>
               </a:srgbClr>
             </a:outerShdw>
           </a:effectLst>
@@ -8759,7 +8925,7 @@
             <a:r>
               <a:rPr lang="en-US" sz="1400" b="1" dirty="0">
                 <a:solidFill>
-                  <a:srgbClr val="333333"/>
+                  <a:srgbClr val="222222"/>
                 </a:solidFill>
                 <a:latin typeface="Calibri" pitchFamily="34" charset="0"/>
                 <a:ea typeface="Calibri" pitchFamily="34" charset="-122"/>
@@ -8837,13 +9003,13 @@
             <a:r>
               <a:rPr lang="en-US" sz="1000" dirty="0">
                 <a:solidFill>
-                  <a:srgbClr val="666666"/>
+                  <a:srgbClr val="555555"/>
                 </a:solidFill>
                 <a:latin typeface="Calibri Light" pitchFamily="34" charset="0"/>
                 <a:ea typeface="Calibri Light" pitchFamily="34" charset="-122"/>
                 <a:cs typeface="Calibri Light" pitchFamily="34" charset="-120"/>
               </a:rPr>
-              <a:t>Debug mode, summary reports, project documentation</a:t>
+              <a:t>Debug mode, summary reports, project docs</a:t>
             </a:r>
             <a:endParaRPr lang="en-US" sz="1000" dirty="0"/>
           </a:p>
@@ -8877,8 +9043,8 @@
         </p:nvSpPr>
         <p:spPr>
           <a:xfrm>
-            <a:off x="457200" y="4709160"/>
-            <a:ext cx="8229600" cy="411480"/>
+            <a:off x="274320" y="4709160"/>
+            <a:ext cx="8595360" cy="411480"/>
           </a:xfrm>
           <a:prstGeom prst="rect">
             <a:avLst/>
@@ -8916,7 +9082,7 @@
         </p:nvSpPr>
         <p:spPr>
           <a:xfrm>
-            <a:off x="7772400" y="4572000"/>
+            <a:off x="7772400" y="4754880"/>
             <a:ext cx="1097280" cy="320040"/>
           </a:xfrm>
           <a:prstGeom prst="rect">
@@ -9007,7 +9173,7 @@
         </p:nvSpPr>
         <p:spPr>
           <a:xfrm>
-            <a:off x="640080" y="1188720"/>
+            <a:off x="640080" y="1005840"/>
             <a:ext cx="7772400" cy="914400"/>
           </a:xfrm>
           <a:prstGeom prst="rect">
@@ -9046,7 +9212,7 @@
         </p:nvSpPr>
         <p:spPr>
           <a:xfrm>
-            <a:off x="640080" y="2103120"/>
+            <a:off x="640080" y="1920240"/>
             <a:ext cx="7772400" cy="457200"/>
           </a:xfrm>
           <a:prstGeom prst="rect">
@@ -9085,7 +9251,7 @@
         </p:nvSpPr>
         <p:spPr>
           <a:xfrm>
-            <a:off x="640080" y="2743200"/>
+            <a:off x="640080" y="2560320"/>
             <a:ext cx="3657600" cy="457200"/>
           </a:xfrm>
           <a:prstGeom prst="rect">
@@ -9112,7 +9278,7 @@
         </p:nvSpPr>
         <p:spPr>
           <a:xfrm>
-            <a:off x="822960" y="2743200"/>
+            <a:off x="822960" y="2560320"/>
             <a:ext cx="3474720" cy="457200"/>
           </a:xfrm>
           <a:prstGeom prst="rect">
@@ -9137,7 +9303,7 @@
                 <a:ea typeface="Calibri" pitchFamily="34" charset="-122"/>
                 <a:cs typeface="Calibri" pitchFamily="34" charset="-120"/>
               </a:rPr>
-              <a:t>🔗  github.com/indrad3v4/Kernel-Olympics</a:t>
+              <a:t>github.com/indrad3v4/Kernel-Olympics</a:t>
             </a:r>
             <a:endParaRPr lang="en-US" sz="1300" dirty="0"/>
           </a:p>
@@ -9151,7 +9317,7 @@
         </p:nvSpPr>
         <p:spPr>
           <a:xfrm>
-            <a:off x="4754880" y="2743200"/>
+            <a:off x="4754880" y="2560320"/>
             <a:ext cx="3657600" cy="457200"/>
           </a:xfrm>
           <a:prstGeom prst="rect">
@@ -9178,7 +9344,7 @@
         </p:nvSpPr>
         <p:spPr>
           <a:xfrm>
-            <a:off x="4937760" y="2743200"/>
+            <a:off x="4937760" y="2560320"/>
             <a:ext cx="3474720" cy="457200"/>
           </a:xfrm>
           <a:prstGeom prst="rect">
@@ -9203,7 +9369,7 @@
                 <a:ea typeface="Calibri" pitchFamily="34" charset="-122"/>
                 <a:cs typeface="Calibri" pitchFamily="34" charset="-120"/>
               </a:rPr>
-              <a:t>🌐  endearing-rebirth.up.railway.app</a:t>
+              <a:t>endearing-rebirth.up.railway.app</a:t>
             </a:r>
             <a:endParaRPr lang="en-US" sz="1300" dirty="0"/>
           </a:p>
@@ -9217,7 +9383,7 @@
         </p:nvSpPr>
         <p:spPr>
           <a:xfrm>
-            <a:off x="640080" y="3474720"/>
+            <a:off x="640080" y="3383280"/>
             <a:ext cx="3657600" cy="457200"/>
           </a:xfrm>
           <a:prstGeom prst="rect">
@@ -9256,8 +9422,8 @@
         </p:nvSpPr>
         <p:spPr>
           <a:xfrm>
-            <a:off x="0" y="4846320"/>
-            <a:ext cx="9144000" cy="297180"/>
+            <a:off x="0" y="4754880"/>
+            <a:ext cx="9144000" cy="388620"/>
           </a:xfrm>
           <a:prstGeom prst="rect">
             <a:avLst/>
@@ -9276,8 +9442,8 @@
         </p:nvSpPr>
         <p:spPr>
           <a:xfrm>
-            <a:off x="457200" y="4846320"/>
-            <a:ext cx="8229600" cy="297180"/>
+            <a:off x="274320" y="4773168"/>
+            <a:ext cx="8595360" cy="365760"/>
           </a:xfrm>
           <a:prstGeom prst="rect">
             <a:avLst/>

</xml_diff>

<commit_message>
fix: update Railway URL to kernel-olympics-production.up.railway.app
</commit_message>
<xml_diff>
--- a/slides/KernelOlympics_Deck.pptx
+++ b/slides/KernelOlympics_Deck.pptx
@@ -1856,7 +1856,7 @@
                 <a:ea typeface="Calibri" pitchFamily="34" charset="-122"/>
                 <a:cs typeface="Calibri" pitchFamily="34" charset="-120"/>
               </a:rPr>
-              <a:t>github.com/indrad3v4/Kernel-Olympics  •  endearing-rebirth.up.railway.app</a:t>
+              <a:t>github.com/indrad3v4/Kernel-Olympics  •  kernel-olympics-production.up.railway.app</a:t>
             </a:r>
             <a:endParaRPr lang="en-US" sz="1000" dirty="0"/>
           </a:p>
@@ -9369,7 +9369,7 @@
                 <a:ea typeface="Calibri" pitchFamily="34" charset="-122"/>
                 <a:cs typeface="Calibri" pitchFamily="34" charset="-120"/>
               </a:rPr>
-              <a:t>endearing-rebirth.up.railway.app</a:t>
+              <a:t>kernel-olympics-production.up.railway.app</a:t>
             </a:r>
             <a:endParaRPr lang="en-US" sz="1300" dirty="0"/>
           </a:p>

</xml_diff>